<commit_message>
fix: sequence-level splits, drop motorcycle class, retrain honest metrics
Eliminates patch-level data leakage by splitting UA-DETRAC at the
sequence (MVI_XXXXX) level instead of per-crop, filters crops
under 64px to avoid upscale artifacts, and removes the stale
motorcycle class so the 4-class config matches the actual training.
Adds class-weighted CE plus macro-F1 checkpoint selection, and
tunes the ROCm run script for the Radeon 780M iGPU. Retrained
model: test accuracy 96.44%, macro F1 95.90%, macro AUC 99.59%.

Co-Authored-By: Claude Opus 4.7 <noreply@anthropic.com>
</commit_message>
<xml_diff>
--- a/EPL445_Interim2_MobileViT_Presentation.pptx
+++ b/EPL445_Interim2_MobileViT_Presentation.pptx
@@ -102,7 +102,84 @@
                 <a:uFillTx/>
                 <a:latin typeface="Calibri"/>
               </a:rPr>
-              <a:t>Click to edit Master title style</a:t>
+              <a:t>Clic</a:t>
+            </a:r>
+            <a:r>
+              <a:rPr lang="en-US" sz="4400" b="0" u="none" strike="noStrike">
+                <a:solidFill>
+                  <a:schemeClr val="dk1"/>
+                </a:solidFill>
+                <a:effectLst/>
+                <a:uFillTx/>
+                <a:latin typeface="Calibri"/>
+              </a:rPr>
+              <a:t>k to </a:t>
+            </a:r>
+            <a:r>
+              <a:rPr lang="en-US" sz="4400" b="0" u="none" strike="noStrike">
+                <a:solidFill>
+                  <a:schemeClr val="dk1"/>
+                </a:solidFill>
+                <a:effectLst/>
+                <a:uFillTx/>
+                <a:latin typeface="Calibri"/>
+              </a:rPr>
+              <a:t>edit </a:t>
+            </a:r>
+            <a:r>
+              <a:rPr lang="en-US" sz="4400" b="0" u="none" strike="noStrike">
+                <a:solidFill>
+                  <a:schemeClr val="dk1"/>
+                </a:solidFill>
+                <a:effectLst/>
+                <a:uFillTx/>
+                <a:latin typeface="Calibri"/>
+              </a:rPr>
+              <a:t>Mas</a:t>
+            </a:r>
+            <a:r>
+              <a:rPr lang="en-US" sz="4400" b="0" u="none" strike="noStrike">
+                <a:solidFill>
+                  <a:schemeClr val="dk1"/>
+                </a:solidFill>
+                <a:effectLst/>
+                <a:uFillTx/>
+                <a:latin typeface="Calibri"/>
+              </a:rPr>
+              <a:t>ter </a:t>
+            </a:r>
+            <a:r>
+              <a:rPr lang="en-US" sz="4400" b="0" u="none" strike="noStrike">
+                <a:solidFill>
+                  <a:schemeClr val="dk1"/>
+                </a:solidFill>
+                <a:effectLst/>
+                <a:uFillTx/>
+                <a:latin typeface="Calibri"/>
+              </a:rPr>
+              <a:t>title </a:t>
+            </a:r>
+            <a:r>
+              <a:rPr lang="en-US" sz="4400" b="0" u="none" strike="noStrike">
+                <a:solidFill>
+                  <a:schemeClr val="dk1"/>
+                </a:solidFill>
+                <a:effectLst/>
+                <a:uFillTx/>
+                <a:latin typeface="Calibri"/>
+              </a:rPr>
+              <a:t>styl</a:t>
+            </a:r>
+            <a:r>
+              <a:rPr lang="en-US" sz="4400" b="0" u="none" strike="noStrike">
+                <a:solidFill>
+                  <a:schemeClr val="dk1"/>
+                </a:solidFill>
+                <a:effectLst/>
+                <a:uFillTx/>
+                <a:latin typeface="Calibri"/>
+              </a:rPr>
+              <a:t>e</a:t>
             </a:r>
             <a:endParaRPr lang="en-US" sz="4400" b="0" u="none" strike="noStrike">
               <a:solidFill>
@@ -309,7 +386,7 @@
               </a:lnSpc>
               <a:buNone/>
             </a:pPr>
-            <a:fld id="{B1C83873-4EF9-41D4-AC04-E848EA4EF362}" type="slidenum">
+            <a:fld id="{27947781-0DD2-4209-9BF6-F976F0B330B7}" type="slidenum">
               <a:rPr lang="en-US" sz="1200" b="0" u="none" strike="noStrike">
                 <a:solidFill>
                   <a:schemeClr val="dk1">
@@ -421,29 +498,7 @@
                 <a:uFillTx/>
                 <a:latin typeface="Calibri"/>
               </a:rPr>
-              <a:t>Click to edit </a:t>
-            </a:r>
-            <a:r>
-              <a:rPr lang="en-US" sz="2000" b="1" u="none" strike="noStrike">
-                <a:solidFill>
-                  <a:schemeClr val="dk1"/>
-                </a:solidFill>
-                <a:effectLst/>
-                <a:uFillTx/>
-                <a:latin typeface="Calibri"/>
-              </a:rPr>
-              <a:t>Master title </a:t>
-            </a:r>
-            <a:r>
-              <a:rPr lang="en-US" sz="2000" b="1" u="none" strike="noStrike">
-                <a:solidFill>
-                  <a:schemeClr val="dk1"/>
-                </a:solidFill>
-                <a:effectLst/>
-                <a:uFillTx/>
-                <a:latin typeface="Calibri"/>
-              </a:rPr>
-              <a:t>style</a:t>
+              <a:t>Click to edit Master title style</a:t>
             </a:r>
             <a:endParaRPr lang="en-US" sz="2000" b="1" u="none" strike="noStrike">
               <a:solidFill>
@@ -1040,7 +1095,7 @@
               </a:lnSpc>
               <a:buNone/>
             </a:pPr>
-            <a:fld id="{AB75A2DB-AFF5-493E-A7DB-2C7B7152678C}" type="slidenum">
+            <a:fld id="{B8E9FC86-9F57-4F04-B3AA-51EE3168D981}" type="slidenum">
               <a:rPr lang="en-US" sz="1200" b="0" u="none" strike="noStrike">
                 <a:solidFill>
                   <a:schemeClr val="dk1">
@@ -1868,7 +1923,7 @@
               </a:lnSpc>
               <a:buNone/>
             </a:pPr>
-            <a:fld id="{900292E9-432C-4837-AD38-C363F79BD3AE}" type="slidenum">
+            <a:fld id="{CD163ECA-39D8-48E2-B4D0-248C8528C332}" type="slidenum">
               <a:rPr lang="en-US" sz="1200" b="0" u="none" strike="noStrike">
                 <a:solidFill>
                   <a:schemeClr val="dk1">
@@ -1980,7 +2035,7 @@
                 <a:uFillTx/>
                 <a:latin typeface="Calibri"/>
               </a:rPr>
-              <a:t>Click </a:t>
+              <a:t>Click to </a:t>
             </a:r>
             <a:r>
               <a:rPr lang="en-US" sz="4400" b="0" u="none" strike="noStrike">
@@ -1991,7 +2046,7 @@
                 <a:uFillTx/>
                 <a:latin typeface="Calibri"/>
               </a:rPr>
-              <a:t>to </a:t>
+              <a:t>edit </a:t>
             </a:r>
             <a:r>
               <a:rPr lang="en-US" sz="4400" b="0" u="none" strike="noStrike">
@@ -2002,29 +2057,7 @@
                 <a:uFillTx/>
                 <a:latin typeface="Calibri"/>
               </a:rPr>
-              <a:t>edit </a:t>
-            </a:r>
-            <a:r>
-              <a:rPr lang="en-US" sz="4400" b="0" u="none" strike="noStrike">
-                <a:solidFill>
-                  <a:schemeClr val="dk1"/>
-                </a:solidFill>
-                <a:effectLst/>
-                <a:uFillTx/>
-                <a:latin typeface="Calibri"/>
-              </a:rPr>
-              <a:t>Mast</a:t>
-            </a:r>
-            <a:r>
-              <a:rPr lang="en-US" sz="4400" b="0" u="none" strike="noStrike">
-                <a:solidFill>
-                  <a:schemeClr val="dk1"/>
-                </a:solidFill>
-                <a:effectLst/>
-                <a:uFillTx/>
-                <a:latin typeface="Calibri"/>
-              </a:rPr>
-              <a:t>er </a:t>
+              <a:t>Master </a:t>
             </a:r>
             <a:r>
               <a:rPr lang="en-US" sz="4400" b="0" u="none" strike="noStrike">
@@ -2559,7 +2592,7 @@
               </a:lnSpc>
               <a:buNone/>
             </a:pPr>
-            <a:fld id="{AFEB9586-445A-4166-A23F-CFA57782D49D}" type="slidenum">
+            <a:fld id="{07159EB3-D150-4A4E-9EE8-1A58F134E6DB}" type="slidenum">
               <a:rPr lang="en-US" sz="1200" b="0" u="none" strike="noStrike">
                 <a:solidFill>
                   <a:schemeClr val="dk1">
@@ -3525,7 +3558,7 @@
               </a:lnSpc>
               <a:buNone/>
             </a:pPr>
-            <a:fld id="{0E688F26-9ED8-4636-979D-7EA5D591DE90}" type="slidenum">
+            <a:fld id="{DBFBFBDC-81E9-442A-9139-5698CD03E8B6}" type="slidenum">
               <a:rPr lang="en-US" sz="1200" b="0" u="none" strike="noStrike">
                 <a:solidFill>
                   <a:schemeClr val="dk1">
@@ -3637,7 +3670,7 @@
                 <a:uFillTx/>
                 <a:latin typeface="Calibri"/>
               </a:rPr>
-              <a:t>Click to </a:t>
+              <a:t>Clic</a:t>
             </a:r>
             <a:r>
               <a:rPr lang="en-US" sz="4400" b="0" u="none" strike="noStrike">
@@ -3648,6 +3681,17 @@
                 <a:uFillTx/>
                 <a:latin typeface="Calibri"/>
               </a:rPr>
+              <a:t>k to </a:t>
+            </a:r>
+            <a:r>
+              <a:rPr lang="en-US" sz="4400" b="0" u="none" strike="noStrike">
+                <a:solidFill>
+                  <a:schemeClr val="dk1"/>
+                </a:solidFill>
+                <a:effectLst/>
+                <a:uFillTx/>
+                <a:latin typeface="Calibri"/>
+              </a:rPr>
               <a:t>edit </a:t>
             </a:r>
             <a:r>
@@ -3659,7 +3703,7 @@
                 <a:uFillTx/>
                 <a:latin typeface="Calibri"/>
               </a:rPr>
-              <a:t>Master </a:t>
+              <a:t>Mas</a:t>
             </a:r>
             <a:r>
               <a:rPr lang="en-US" sz="4400" b="0" u="none" strike="noStrike">
@@ -3670,6 +3714,17 @@
                 <a:uFillTx/>
                 <a:latin typeface="Calibri"/>
               </a:rPr>
+              <a:t>ter </a:t>
+            </a:r>
+            <a:r>
+              <a:rPr lang="en-US" sz="4400" b="0" u="none" strike="noStrike">
+                <a:solidFill>
+                  <a:schemeClr val="dk1"/>
+                </a:solidFill>
+                <a:effectLst/>
+                <a:uFillTx/>
+                <a:latin typeface="Calibri"/>
+              </a:rPr>
               <a:t>title </a:t>
             </a:r>
             <a:r>
@@ -3681,7 +3736,18 @@
                 <a:uFillTx/>
                 <a:latin typeface="Calibri"/>
               </a:rPr>
-              <a:t>style</a:t>
+              <a:t>styl</a:t>
+            </a:r>
+            <a:r>
+              <a:rPr lang="en-US" sz="4400" b="0" u="none" strike="noStrike">
+                <a:solidFill>
+                  <a:schemeClr val="dk1"/>
+                </a:solidFill>
+                <a:effectLst/>
+                <a:uFillTx/>
+                <a:latin typeface="Calibri"/>
+              </a:rPr>
+              <a:t>e</a:t>
             </a:r>
             <a:endParaRPr lang="en-US" sz="4400" b="0" u="none" strike="noStrike">
               <a:solidFill>
@@ -4194,7 +4260,7 @@
               </a:lnSpc>
               <a:buNone/>
             </a:pPr>
-            <a:fld id="{3664C2D4-655C-4988-A814-C2D1B65C9CEF}" type="slidenum">
+            <a:fld id="{374E2AB4-518D-40E5-9E8B-389E9BEB12A2}" type="slidenum">
               <a:rPr lang="en-US" sz="1200" b="0" u="none" strike="noStrike">
                 <a:solidFill>
                   <a:schemeClr val="dk1">
@@ -4306,7 +4372,7 @@
                 <a:uFillTx/>
                 <a:latin typeface="Calibri"/>
               </a:rPr>
-              <a:t>Clic</a:t>
+              <a:t>Click </a:t>
             </a:r>
             <a:r>
               <a:rPr lang="en-US" sz="4000" b="1" u="none" strike="noStrike" cap="all">
@@ -4317,7 +4383,7 @@
                 <a:uFillTx/>
                 <a:latin typeface="Calibri"/>
               </a:rPr>
-              <a:t>k to </a:t>
+              <a:t>to edit </a:t>
             </a:r>
             <a:r>
               <a:rPr lang="en-US" sz="4000" b="1" u="none" strike="noStrike" cap="all">
@@ -4328,7 +4394,7 @@
                 <a:uFillTx/>
                 <a:latin typeface="Calibri"/>
               </a:rPr>
-              <a:t>edit </a:t>
+              <a:t>Maste</a:t>
             </a:r>
             <a:r>
               <a:rPr lang="en-US" sz="4000" b="1" u="none" strike="noStrike" cap="all">
@@ -4339,7 +4405,7 @@
                 <a:uFillTx/>
                 <a:latin typeface="Calibri"/>
               </a:rPr>
-              <a:t>Mas</a:t>
+              <a:t>r title </a:t>
             </a:r>
             <a:r>
               <a:rPr lang="en-US" sz="4000" b="1" u="none" strike="noStrike" cap="all">
@@ -4350,40 +4416,7 @@
                 <a:uFillTx/>
                 <a:latin typeface="Calibri"/>
               </a:rPr>
-              <a:t>ter </a:t>
-            </a:r>
-            <a:r>
-              <a:rPr lang="en-US" sz="4000" b="1" u="none" strike="noStrike" cap="all">
-                <a:solidFill>
-                  <a:schemeClr val="dk1"/>
-                </a:solidFill>
-                <a:effectLst/>
-                <a:uFillTx/>
-                <a:latin typeface="Calibri"/>
-              </a:rPr>
-              <a:t>title </a:t>
-            </a:r>
-            <a:r>
-              <a:rPr lang="en-US" sz="4000" b="1" u="none" strike="noStrike" cap="all">
-                <a:solidFill>
-                  <a:schemeClr val="dk1"/>
-                </a:solidFill>
-                <a:effectLst/>
-                <a:uFillTx/>
-                <a:latin typeface="Calibri"/>
-              </a:rPr>
-              <a:t>styl</a:t>
-            </a:r>
-            <a:r>
-              <a:rPr lang="en-US" sz="4000" b="1" u="none" strike="noStrike" cap="all">
-                <a:solidFill>
-                  <a:schemeClr val="dk1"/>
-                </a:solidFill>
-                <a:effectLst/>
-                <a:uFillTx/>
-                <a:latin typeface="Calibri"/>
-              </a:rPr>
-              <a:t>e</a:t>
+              <a:t>style</a:t>
             </a:r>
             <a:endParaRPr lang="en-US" sz="4000" b="1" u="none" strike="noStrike" cap="all">
               <a:solidFill>
@@ -4680,7 +4713,7 @@
               </a:lnSpc>
               <a:buNone/>
             </a:pPr>
-            <a:fld id="{51BBFF27-9E5F-4970-AC2B-698ADEFECA5E}" type="slidenum">
+            <a:fld id="{A07AEC86-3119-4CC3-9C41-1A94699DEB00}" type="slidenum">
               <a:rPr lang="en-US" sz="1200" b="0" u="none" strike="noStrike">
                 <a:solidFill>
                   <a:schemeClr val="dk1">
@@ -4792,7 +4825,7 @@
                 <a:uFillTx/>
                 <a:latin typeface="Calibri"/>
               </a:rPr>
-              <a:t>Clic</a:t>
+              <a:t>Click </a:t>
             </a:r>
             <a:r>
               <a:rPr lang="en-US" sz="4400" b="0" u="none" strike="noStrike">
@@ -4803,7 +4836,7 @@
                 <a:uFillTx/>
                 <a:latin typeface="Calibri"/>
               </a:rPr>
-              <a:t>k to </a:t>
+              <a:t>to </a:t>
             </a:r>
             <a:r>
               <a:rPr lang="en-US" sz="4400" b="0" u="none" strike="noStrike">
@@ -4825,7 +4858,7 @@
                 <a:uFillTx/>
                 <a:latin typeface="Calibri"/>
               </a:rPr>
-              <a:t>Mas</a:t>
+              <a:t>Mast</a:t>
             </a:r>
             <a:r>
               <a:rPr lang="en-US" sz="4400" b="0" u="none" strike="noStrike">
@@ -4836,7 +4869,7 @@
                 <a:uFillTx/>
                 <a:latin typeface="Calibri"/>
               </a:rPr>
-              <a:t>ter </a:t>
+              <a:t>er </a:t>
             </a:r>
             <a:r>
               <a:rPr lang="en-US" sz="4400" b="0" u="none" strike="noStrike">
@@ -4858,18 +4891,7 @@
                 <a:uFillTx/>
                 <a:latin typeface="Calibri"/>
               </a:rPr>
-              <a:t>styl</a:t>
-            </a:r>
-            <a:r>
-              <a:rPr lang="en-US" sz="4400" b="0" u="none" strike="noStrike">
-                <a:solidFill>
-                  <a:schemeClr val="dk1"/>
-                </a:solidFill>
-                <a:effectLst/>
-                <a:uFillTx/>
-                <a:latin typeface="Calibri"/>
-              </a:rPr>
-              <a:t>e</a:t>
+              <a:t>style</a:t>
             </a:r>
             <a:endParaRPr lang="en-US" sz="4400" b="0" u="none" strike="noStrike">
               <a:solidFill>
@@ -5688,7 +5710,7 @@
               </a:lnSpc>
               <a:buNone/>
             </a:pPr>
-            <a:fld id="{FE6EF52D-9C98-4270-9E5F-2989325897C1}" type="slidenum">
+            <a:fld id="{7E76A591-ACA7-4FC5-9874-B8D6AD288579}" type="slidenum">
               <a:rPr lang="en-US" sz="1200" b="0" u="none" strike="noStrike">
                 <a:solidFill>
                   <a:schemeClr val="dk1">
@@ -5800,7 +5822,7 @@
                 <a:uFillTx/>
                 <a:latin typeface="Calibri"/>
               </a:rPr>
-              <a:t>Click to </a:t>
+              <a:t>Clic</a:t>
             </a:r>
             <a:r>
               <a:rPr lang="en-US" sz="4400" b="0" u="none" strike="noStrike">
@@ -5811,6 +5833,17 @@
                 <a:uFillTx/>
                 <a:latin typeface="Calibri"/>
               </a:rPr>
+              <a:t>k to </a:t>
+            </a:r>
+            <a:r>
+              <a:rPr lang="en-US" sz="4400" b="0" u="none" strike="noStrike">
+                <a:solidFill>
+                  <a:schemeClr val="dk1"/>
+                </a:solidFill>
+                <a:effectLst/>
+                <a:uFillTx/>
+                <a:latin typeface="Calibri"/>
+              </a:rPr>
               <a:t>edit </a:t>
             </a:r>
             <a:r>
@@ -5822,7 +5855,7 @@
                 <a:uFillTx/>
                 <a:latin typeface="Calibri"/>
               </a:rPr>
-              <a:t>Master </a:t>
+              <a:t>Mas</a:t>
             </a:r>
             <a:r>
               <a:rPr lang="en-US" sz="4400" b="0" u="none" strike="noStrike">
@@ -5833,6 +5866,17 @@
                 <a:uFillTx/>
                 <a:latin typeface="Calibri"/>
               </a:rPr>
+              <a:t>ter </a:t>
+            </a:r>
+            <a:r>
+              <a:rPr lang="en-US" sz="4400" b="0" u="none" strike="noStrike">
+                <a:solidFill>
+                  <a:schemeClr val="dk1"/>
+                </a:solidFill>
+                <a:effectLst/>
+                <a:uFillTx/>
+                <a:latin typeface="Calibri"/>
+              </a:rPr>
               <a:t>title </a:t>
             </a:r>
             <a:r>
@@ -5844,7 +5888,18 @@
                 <a:uFillTx/>
                 <a:latin typeface="Calibri"/>
               </a:rPr>
-              <a:t>style</a:t>
+              <a:t>styl</a:t>
+            </a:r>
+            <a:r>
+              <a:rPr lang="en-US" sz="4400" b="0" u="none" strike="noStrike">
+                <a:solidFill>
+                  <a:schemeClr val="dk1"/>
+                </a:solidFill>
+                <a:effectLst/>
+                <a:uFillTx/>
+                <a:latin typeface="Calibri"/>
+              </a:rPr>
+              <a:t>e</a:t>
             </a:r>
             <a:endParaRPr lang="en-US" sz="4400" b="0" u="none" strike="noStrike">
               <a:solidFill>
@@ -6891,7 +6946,7 @@
               </a:lnSpc>
               <a:buNone/>
             </a:pPr>
-            <a:fld id="{4DF60869-0826-4087-A172-B8D6D2196C4A}" type="slidenum">
+            <a:fld id="{C1E85488-B1DF-4FA8-8E97-F92773BD4CB6}" type="slidenum">
               <a:rPr lang="en-US" sz="1200" b="0" u="none" strike="noStrike">
                 <a:solidFill>
                   <a:schemeClr val="dk1">
@@ -7254,7 +7309,7 @@
               </a:lnSpc>
               <a:buNone/>
             </a:pPr>
-            <a:fld id="{A6FD9152-75DC-4947-B3B5-C554AD526094}" type="slidenum">
+            <a:fld id="{5D1FB09F-0702-4088-BDC4-0962C56F1552}" type="slidenum">
               <a:rPr lang="en-US" sz="1200" b="0" u="none" strike="noStrike">
                 <a:solidFill>
                   <a:schemeClr val="dk1">
@@ -7501,7 +7556,7 @@
               </a:lnSpc>
               <a:buNone/>
             </a:pPr>
-            <a:fld id="{30BB3EE2-3F68-443A-85C6-A6413CA7380A}" type="slidenum">
+            <a:fld id="{AACD97BD-E492-47E2-B9A1-0BAA84C05182}" type="slidenum">
               <a:rPr lang="en-US" sz="1200" b="0" u="none" strike="noStrike">
                 <a:solidFill>
                   <a:schemeClr val="dk1">
@@ -7589,7 +7644,7 @@
                 <a:uFillTx/>
                 <a:latin typeface="Calibri"/>
               </a:rPr>
-              <a:t>to </a:t>
+              <a:t>to edit </a:t>
             </a:r>
             <a:r>
               <a:rPr lang="en-US" sz="4400" b="0" u="none" strike="noStrike">
@@ -7600,7 +7655,7 @@
                 <a:uFillTx/>
                 <a:latin typeface="Calibri"/>
               </a:rPr>
-              <a:t>edit </a:t>
+              <a:t>the </a:t>
             </a:r>
             <a:r>
               <a:rPr lang="en-US" sz="4400" b="0" u="none" strike="noStrike">
@@ -7611,7 +7666,7 @@
                 <a:uFillTx/>
                 <a:latin typeface="Calibri"/>
               </a:rPr>
-              <a:t>the </a:t>
+              <a:t>title </a:t>
             </a:r>
             <a:r>
               <a:rPr lang="en-US" sz="4400" b="0" u="none" strike="noStrike">
@@ -7622,7 +7677,7 @@
                 <a:uFillTx/>
                 <a:latin typeface="Calibri"/>
               </a:rPr>
-              <a:t>title </a:t>
+              <a:t>text </a:t>
             </a:r>
             <a:r>
               <a:rPr lang="en-US" sz="4400" b="0" u="none" strike="noStrike">
@@ -7633,29 +7688,7 @@
                 <a:uFillTx/>
                 <a:latin typeface="Calibri"/>
               </a:rPr>
-              <a:t>text </a:t>
-            </a:r>
-            <a:r>
-              <a:rPr lang="en-US" sz="4400" b="0" u="none" strike="noStrike">
-                <a:solidFill>
-                  <a:schemeClr val="dk1"/>
-                </a:solidFill>
-                <a:effectLst/>
-                <a:uFillTx/>
-                <a:latin typeface="Calibri"/>
-              </a:rPr>
-              <a:t>form</a:t>
-            </a:r>
-            <a:r>
-              <a:rPr lang="en-US" sz="4400" b="0" u="none" strike="noStrike">
-                <a:solidFill>
-                  <a:schemeClr val="dk1"/>
-                </a:solidFill>
-                <a:effectLst/>
-                <a:uFillTx/>
-                <a:latin typeface="Calibri"/>
-              </a:rPr>
-              <a:t>at</a:t>
+              <a:t>format</a:t>
             </a:r>
             <a:endParaRPr lang="en-US" sz="4400" b="0" u="none" strike="noStrike">
               <a:solidFill>
@@ -8805,7 +8838,7 @@
           <a:fontRef idx="minor"/>
         </p:style>
         <p:txBody>
-          <a:bodyPr wrap="none" lIns="90000" tIns="45000" rIns="90000" bIns="45000" anchor="ctr">
+          <a:bodyPr lIns="90000" tIns="45000" rIns="90000" bIns="45000" anchor="ctr">
             <a:noAutofit/>
           </a:bodyPr>
           <a:p>
@@ -9418,7 +9451,7 @@
           <a:fontRef idx="minor"/>
         </p:style>
         <p:txBody>
-          <a:bodyPr wrap="none" lIns="90000" tIns="45000" rIns="90000" bIns="45000" anchor="ctr">
+          <a:bodyPr lIns="90000" tIns="45000" rIns="90000" bIns="45000" anchor="ctr">
             <a:noAutofit/>
           </a:bodyPr>
           <a:p>
@@ -9839,7 +9872,7 @@
                 <a:uFillTx/>
                 <a:latin typeface="Calibri"/>
               </a:rPr>
-              <a:t>FIRST RUNS — demonstrate a working, end-to-end pipeline using lightweight models on video frames; verify all metrics on the test set.</a:t>
+              <a:t>FIRST RUNS — demonstrate a working, end-to-end pipeline using lightweight models on video frames; verify all metrics on a held-out test set.</a:t>
             </a:r>
             <a:endParaRPr lang="en-US" sz="1300" b="0" u="none" strike="noStrike">
               <a:solidFill>
@@ -10012,7 +10045,7 @@
                 <a:uFillTx/>
                 <a:latin typeface="Calibri"/>
               </a:rPr>
-              <a:t>Light-weight Vision Transformer (ICLR 2022). Balances accuracy and efficiency — designed for mobile/edge deployment without sacrificing performance.</a:t>
+              <a:t>Light-weight Vision Transformer (ICLR 2022). Balances accuracy and efficiency — designed for mobile/edge deployment.</a:t>
             </a:r>
             <a:endParaRPr lang="en-US" sz="1300" b="0" u="none" strike="noStrike">
               <a:solidFill>
@@ -10128,7 +10161,7 @@
                 <a:uFillTx/>
                 <a:latin typeface="Calibri"/>
               </a:rPr>
-              <a:t>Model Source:</a:t>
+              <a:t>Methodological Rigour:</a:t>
             </a:r>
             <a:endParaRPr lang="en-US" sz="1400" b="0" u="none" strike="noStrike">
               <a:solidFill>
@@ -10185,7 +10218,7 @@
                 <a:uFillTx/>
                 <a:latin typeface="Calibri"/>
               </a:rPr>
-              <a:t>Pre-trained MobileViT-S backbone from timm (ImageNet); fine-tuned on UA-DETRAC crops.</a:t>
+              <a:t>We identified and corrected a sequence-level data-leakage issue, retrained on clean splits — results below are honest.</a:t>
             </a:r>
             <a:endParaRPr lang="en-US" sz="1300" b="0" u="none" strike="noStrike">
               <a:solidFill>
@@ -10438,7 +10471,7 @@
           <a:fontRef idx="minor"/>
         </p:style>
         <p:txBody>
-          <a:bodyPr wrap="none" lIns="90000" tIns="45000" rIns="90000" bIns="45000" anchor="ctr">
+          <a:bodyPr lIns="90000" tIns="45000" rIns="90000" bIns="45000" anchor="ctr">
             <a:noAutofit/>
           </a:bodyPr>
           <a:p>
@@ -10629,7 +10662,7 @@
                 <a:uFillTx/>
                 <a:latin typeface="Calibri"/>
               </a:rPr>
-              <a:t>Source: Wen et al., 2020 — urban traffic surveillance sequences</a:t>
+              <a:t>Source: Wen et al., 2020 — urban surveillance</a:t>
             </a:r>
             <a:endParaRPr lang="en-US" sz="1200" b="0" u="none" strike="noStrike">
               <a:solidFill>
@@ -10686,40 +10719,7 @@
                 <a:uFillTx/>
                 <a:latin typeface="Calibri"/>
               </a:rPr>
-              <a:t>~475,000 cropped </a:t>
-            </a:r>
-            <a:r>
-              <a:rPr lang="en-US" sz="1200" b="0" u="none" strike="noStrike">
-                <a:solidFill>
-                  <a:srgbClr val="333333"/>
-                </a:solidFill>
-                <a:effectLst/>
-                <a:uFillTx/>
-                <a:latin typeface="Calibri"/>
-              </a:rPr>
-              <a:t>vehicle patches </a:t>
-            </a:r>
-            <a:r>
-              <a:rPr lang="en-US" sz="1200" b="0" u="none" strike="noStrike">
-                <a:solidFill>
-                  <a:srgbClr val="333333"/>
-                </a:solidFill>
-                <a:effectLst/>
-                <a:uFillTx/>
-                <a:latin typeface="Calibri"/>
-              </a:rPr>
-              <a:t>extracted from </a:t>
-            </a:r>
-            <a:r>
-              <a:rPr lang="en-US" sz="1200" b="0" u="none" strike="noStrike">
-                <a:solidFill>
-                  <a:srgbClr val="333333"/>
-                </a:solidFill>
-                <a:effectLst/>
-                <a:uFillTx/>
-                <a:latin typeface="Calibri"/>
-              </a:rPr>
-              <a:t>annotated frames</a:t>
+              <a:t>4 classes: car | bus | truck | background</a:t>
             </a:r>
             <a:endParaRPr lang="en-US" sz="1200" b="0" u="none" strike="noStrike">
               <a:solidFill>
@@ -10776,7 +10776,7 @@
                 <a:uFillTx/>
                 <a:latin typeface="Calibri"/>
               </a:rPr>
-              <a:t>4 Classes:  Car  |  Bus  |  Truck  |  Background</a:t>
+              <a:t>100 video sequences total</a:t>
             </a:r>
             <a:endParaRPr lang="en-US" sz="1200" b="0" u="none" strike="noStrike">
               <a:solidFill>
@@ -10833,7 +10833,7 @@
                 <a:uFillTx/>
                 <a:latin typeface="Calibri"/>
               </a:rPr>
-              <a:t>Stratified train / val / test split</a:t>
+              <a:t>Sequence-level split (no leakage)</a:t>
             </a:r>
             <a:endParaRPr lang="en-US" sz="1200" b="0" u="none" strike="noStrike">
               <a:solidFill>
@@ -10890,7 +10890,7 @@
                 <a:uFillTx/>
                 <a:latin typeface="Calibri"/>
               </a:rPr>
-              <a:t>   Train   — 19,225 samples</a:t>
+              <a:t>   Train  — 69 sequences,  6,827 patches</a:t>
             </a:r>
             <a:endParaRPr lang="en-US" sz="1200" b="0" u="none" strike="noStrike">
               <a:solidFill>
@@ -10947,29 +10947,7 @@
                 <a:uFillTx/>
                 <a:latin typeface="Calibri"/>
               </a:rPr>
-              <a:t>   Val      — </a:t>
-            </a:r>
-            <a:r>
-              <a:rPr lang="en-US" sz="1200" b="0" u="none" strike="noStrike">
-                <a:solidFill>
-                  <a:srgbClr val="333333"/>
-                </a:solidFill>
-                <a:effectLst/>
-                <a:uFillTx/>
-                <a:latin typeface="Calibri"/>
-              </a:rPr>
-              <a:t>2,552 </a:t>
-            </a:r>
-            <a:r>
-              <a:rPr lang="en-US" sz="1200" b="0" u="none" strike="noStrike">
-                <a:solidFill>
-                  <a:srgbClr val="333333"/>
-                </a:solidFill>
-                <a:effectLst/>
-                <a:uFillTx/>
-                <a:latin typeface="Calibri"/>
-              </a:rPr>
-              <a:t>samples</a:t>
+              <a:t>   Val    — 15 sequences,    928 patches</a:t>
             </a:r>
             <a:endParaRPr lang="en-US" sz="1200" b="0" u="none" strike="noStrike">
               <a:solidFill>
@@ -11026,7 +11004,7 @@
                 <a:uFillTx/>
                 <a:latin typeface="Calibri"/>
               </a:rPr>
-              <a:t>   Test     — 2,551 samples</a:t>
+              <a:t>   Test   — 16 sequences,  2,614 patches</a:t>
             </a:r>
             <a:endParaRPr lang="en-US" sz="1200" b="0" u="none" strike="noStrike">
               <a:solidFill>
@@ -11083,7 +11061,7 @@
                 <a:uFillTx/>
                 <a:latin typeface="Calibri"/>
               </a:rPr>
-              <a:t>Image size: 256 × 256  →  224 × 224 centre-crop</a:t>
+              <a:t>Crops &lt; 64 px filtered to avoid upscale artefacts</a:t>
             </a:r>
             <a:endParaRPr lang="en-US" sz="1200" b="0" u="none" strike="noStrike">
               <a:solidFill>
@@ -11140,7 +11118,7 @@
                 <a:uFillTx/>
                 <a:latin typeface="Calibri"/>
               </a:rPr>
-              <a:t>Augmentation: random flip, colour jitter, normalisation</a:t>
+              <a:t>Image size: 256 × 256 input</a:t>
             </a:r>
             <a:endParaRPr lang="en-US" sz="1200" b="0" u="none" strike="noStrike">
               <a:solidFill>
@@ -11155,7 +11133,64 @@
       </p:sp>
       <p:sp>
         <p:nvSpPr>
-          <p:cNvPr id="111" name="Rectangle 14"/>
+          <p:cNvPr id="111" name="TextBox 14"/>
+          <p:cNvSpPr/>
+          <p:nvPr/>
+        </p:nvSpPr>
+        <p:spPr>
+          <a:xfrm>
+            <a:off x="548640" y="4636080"/>
+            <a:ext cx="4937400" cy="310680"/>
+          </a:xfrm>
+          <a:prstGeom prst="rect">
+            <a:avLst/>
+          </a:prstGeom>
+          <a:noFill/>
+          <a:ln w="0">
+            <a:noFill/>
+          </a:ln>
+        </p:spPr>
+        <p:style>
+          <a:lnRef idx="0"/>
+          <a:fillRef idx="0"/>
+          <a:effectRef idx="0"/>
+          <a:fontRef idx="minor"/>
+        </p:style>
+        <p:txBody>
+          <a:bodyPr wrap="none" lIns="90000" tIns="45000" rIns="90000" bIns="45000" anchor="t">
+            <a:spAutoFit/>
+          </a:bodyPr>
+          <a:p>
+            <a:pPr defTabSz="457200">
+              <a:lnSpc>
+                <a:spcPct val="100000"/>
+              </a:lnSpc>
+            </a:pPr>
+            <a:r>
+              <a:rPr lang="en-US" sz="1200" b="0" u="none" strike="noStrike">
+                <a:solidFill>
+                  <a:srgbClr val="333333"/>
+                </a:solidFill>
+                <a:effectLst/>
+                <a:uFillTx/>
+                <a:latin typeface="Calibri"/>
+              </a:rPr>
+              <a:t>Augmentation: random flip, rotation, colour jitter</a:t>
+            </a:r>
+            <a:endParaRPr lang="en-US" sz="1200" b="0" u="none" strike="noStrike">
+              <a:solidFill>
+                <a:srgbClr val="000000"/>
+              </a:solidFill>
+              <a:effectLst/>
+              <a:uFillTx/>
+              <a:latin typeface="Arial"/>
+            </a:endParaRPr>
+          </a:p>
+        </p:txBody>
+      </p:sp>
+      <p:sp>
+        <p:nvSpPr>
+          <p:cNvPr id="112" name="Rectangle 15"/>
           <p:cNvSpPr/>
           <p:nvPr/>
         </p:nvSpPr>
@@ -11214,7 +11249,7 @@
       </p:sp>
       <p:sp>
         <p:nvSpPr>
-          <p:cNvPr id="112" name="TextBox 15"/>
+          <p:cNvPr id="113" name="TextBox 16"/>
           <p:cNvSpPr/>
           <p:nvPr/>
         </p:nvSpPr>
@@ -11271,7 +11306,7 @@
       </p:sp>
       <p:sp>
         <p:nvSpPr>
-          <p:cNvPr id="113" name="TextBox 16"/>
+          <p:cNvPr id="114" name="TextBox 17"/>
           <p:cNvSpPr/>
           <p:nvPr/>
         </p:nvSpPr>
@@ -11313,7 +11348,7 @@
                 <a:uFillTx/>
                 <a:latin typeface="Calibri"/>
               </a:rPr>
-              <a:t>Staged Fine-Tuning (15 epochs total)</a:t>
+              <a:t>Staged Fine-Tuning (15 epochs)</a:t>
             </a:r>
             <a:endParaRPr lang="en-US" sz="1200" b="0" u="none" strike="noStrike">
               <a:solidFill>
@@ -11328,7 +11363,7 @@
       </p:sp>
       <p:sp>
         <p:nvSpPr>
-          <p:cNvPr id="114" name="TextBox 17"/>
+          <p:cNvPr id="115" name="TextBox 18"/>
           <p:cNvSpPr/>
           <p:nvPr/>
         </p:nvSpPr>
@@ -11370,18 +11405,7 @@
                 <a:uFillTx/>
                 <a:latin typeface="Calibri"/>
               </a:rPr>
-              <a:t>Epochs 1–3:  </a:t>
-            </a:r>
-            <a:r>
-              <a:rPr lang="en-US" sz="1200" b="0" u="none" strike="noStrike">
-                <a:solidFill>
-                  <a:srgbClr val="333333"/>
-                </a:solidFill>
-                <a:effectLst/>
-                <a:uFillTx/>
-                <a:latin typeface="Calibri"/>
-              </a:rPr>
-              <a:t>Backbone frozen</a:t>
+              <a:t>Epochs 1–3:  Backbone frozen</a:t>
             </a:r>
             <a:endParaRPr lang="en-US" sz="1200" b="0" u="none" strike="noStrike">
               <a:solidFill>
@@ -11396,7 +11420,7 @@
       </p:sp>
       <p:sp>
         <p:nvSpPr>
-          <p:cNvPr id="115" name="TextBox 18"/>
+          <p:cNvPr id="116" name="TextBox 19"/>
           <p:cNvSpPr/>
           <p:nvPr/>
         </p:nvSpPr>
@@ -11438,7 +11462,7 @@
                 <a:uFillTx/>
                 <a:latin typeface="Calibri"/>
               </a:rPr>
-              <a:t>         Only classifier head trained (lr = 1e-3)</a:t>
+              <a:t>         Only classifier head trains (lr = 3e-4)</a:t>
             </a:r>
             <a:endParaRPr lang="en-US" sz="1200" b="0" u="none" strike="noStrike">
               <a:solidFill>
@@ -11453,7 +11477,7 @@
       </p:sp>
       <p:sp>
         <p:nvSpPr>
-          <p:cNvPr id="116" name="TextBox 19"/>
+          <p:cNvPr id="117" name="TextBox 20"/>
           <p:cNvSpPr/>
           <p:nvPr/>
         </p:nvSpPr>
@@ -11495,18 +11519,7 @@
                 <a:uFillTx/>
                 <a:latin typeface="Calibri"/>
               </a:rPr>
-              <a:t>Epochs 4–15:  Full model </a:t>
-            </a:r>
-            <a:r>
-              <a:rPr lang="en-US" sz="1200" b="0" u="none" strike="noStrike">
-                <a:solidFill>
-                  <a:srgbClr val="333333"/>
-                </a:solidFill>
-                <a:effectLst/>
-                <a:uFillTx/>
-                <a:latin typeface="Calibri"/>
-              </a:rPr>
-              <a:t>unfrozen</a:t>
+              <a:t>Epochs 4–15:  Full model unfrozen</a:t>
             </a:r>
             <a:endParaRPr lang="en-US" sz="1200" b="0" u="none" strike="noStrike">
               <a:solidFill>
@@ -11521,7 +11534,7 @@
       </p:sp>
       <p:sp>
         <p:nvSpPr>
-          <p:cNvPr id="117" name="TextBox 20"/>
+          <p:cNvPr id="118" name="TextBox 21"/>
           <p:cNvSpPr/>
           <p:nvPr/>
         </p:nvSpPr>
@@ -11563,7 +11576,7 @@
                 <a:uFillTx/>
                 <a:latin typeface="Calibri"/>
               </a:rPr>
-              <a:t>         End-to-end fine-tuning (lr = 1e-4)</a:t>
+              <a:t>         End-to-end fine-tuning (lr = 3e-5)</a:t>
             </a:r>
             <a:endParaRPr lang="en-US" sz="1200" b="0" u="none" strike="noStrike">
               <a:solidFill>
@@ -11578,7 +11591,7 @@
       </p:sp>
       <p:sp>
         <p:nvSpPr>
-          <p:cNvPr id="118" name="TextBox 21"/>
+          <p:cNvPr id="119" name="TextBox 22"/>
           <p:cNvSpPr/>
           <p:nvPr/>
         </p:nvSpPr>
@@ -11635,7 +11648,7 @@
       </p:sp>
       <p:sp>
         <p:nvSpPr>
-          <p:cNvPr id="119" name="TextBox 22"/>
+          <p:cNvPr id="120" name="TextBox 23"/>
           <p:cNvSpPr/>
           <p:nvPr/>
         </p:nvSpPr>
@@ -11677,18 +11690,7 @@
                 <a:uFillTx/>
                 <a:latin typeface="Calibri"/>
               </a:rPr>
-              <a:t>Loss: Cross-</a:t>
-            </a:r>
-            <a:r>
-              <a:rPr lang="en-US" sz="1200" b="0" u="none" strike="noStrike">
-                <a:solidFill>
-                  <a:srgbClr val="333333"/>
-                </a:solidFill>
-                <a:effectLst/>
-                <a:uFillTx/>
-                <a:latin typeface="Calibri"/>
-              </a:rPr>
-              <a:t>Entropy</a:t>
+              <a:t>Loss: Class-weighted Cross-Entropy</a:t>
             </a:r>
             <a:endParaRPr lang="en-US" sz="1200" b="0" u="none" strike="noStrike">
               <a:solidFill>
@@ -11703,7 +11705,7 @@
       </p:sp>
       <p:sp>
         <p:nvSpPr>
-          <p:cNvPr id="120" name="TextBox 23"/>
+          <p:cNvPr id="121" name="TextBox 24"/>
           <p:cNvSpPr/>
           <p:nvPr/>
         </p:nvSpPr>
@@ -11745,7 +11747,7 @@
                 <a:uFillTx/>
                 <a:latin typeface="Calibri"/>
               </a:rPr>
-              <a:t>Hardware: GPU (NVIDIA)  |  Batch size: 64</a:t>
+              <a:t>Hardware: AMD Radeon 780M (ROCm 7.2)  | bs=4</a:t>
             </a:r>
             <a:endParaRPr lang="en-US" sz="1200" b="0" u="none" strike="noStrike">
               <a:solidFill>
@@ -11760,7 +11762,7 @@
       </p:sp>
       <p:sp>
         <p:nvSpPr>
-          <p:cNvPr id="121" name="TextBox 24"/>
+          <p:cNvPr id="122" name="TextBox 25"/>
           <p:cNvSpPr/>
           <p:nvPr/>
         </p:nvSpPr>
@@ -11802,7 +11804,7 @@
                 <a:uFillTx/>
                 <a:latin typeface="Calibri"/>
               </a:rPr>
-              <a:t>Best checkpoint saved at epoch with highest val accuracy</a:t>
+              <a:t>Best checkpoint chosen by val macro-F1</a:t>
             </a:r>
             <a:endParaRPr lang="en-US" sz="1200" b="0" u="none" strike="noStrike">
               <a:solidFill>
@@ -11817,7 +11819,7 @@
       </p:sp>
       <p:sp>
         <p:nvSpPr>
-          <p:cNvPr id="122" name="TextBox 25"/>
+          <p:cNvPr id="123" name="TextBox 26"/>
           <p:cNvSpPr/>
           <p:nvPr/>
         </p:nvSpPr>
@@ -11859,7 +11861,7 @@
                 <a:uFillTx/>
                 <a:latin typeface="Calibri"/>
               </a:rPr>
-              <a:t>Best val accuracy: 96.63%</a:t>
+              <a:t>Best val macro-F1: 94.04%</a:t>
             </a:r>
             <a:endParaRPr lang="en-US" sz="1200" b="0" u="none" strike="noStrike">
               <a:solidFill>
@@ -11874,7 +11876,7 @@
       </p:sp>
       <p:sp>
         <p:nvSpPr>
-          <p:cNvPr id="123" name="TextBox 26"/>
+          <p:cNvPr id="124" name="TextBox 27"/>
           <p:cNvSpPr/>
           <p:nvPr/>
         </p:nvSpPr>
@@ -11931,7 +11933,7 @@
       </p:sp>
       <p:sp>
         <p:nvSpPr>
-          <p:cNvPr id="124" name="Rectangle 27"/>
+          <p:cNvPr id="125" name="Rectangle 28"/>
           <p:cNvSpPr/>
           <p:nvPr/>
         </p:nvSpPr>
@@ -12017,7 +12019,7 @@
       </p:grpSpPr>
       <p:sp>
         <p:nvSpPr>
-          <p:cNvPr id="125" name="Rectangle 1"/>
+          <p:cNvPr id="126" name="Rectangle 1"/>
           <p:cNvSpPr/>
           <p:nvPr/>
         </p:nvSpPr>
@@ -12073,7 +12075,7 @@
       </p:sp>
       <p:sp>
         <p:nvSpPr>
-          <p:cNvPr id="126" name="Rectangle 2"/>
+          <p:cNvPr id="127" name="Rectangle 2"/>
           <p:cNvSpPr/>
           <p:nvPr/>
         </p:nvSpPr>
@@ -12112,7 +12114,7 @@
           <a:fontRef idx="minor"/>
         </p:style>
         <p:txBody>
-          <a:bodyPr wrap="none" lIns="90000" tIns="45000" rIns="90000" bIns="45000" anchor="ctr">
+          <a:bodyPr lIns="90000" tIns="45000" rIns="90000" bIns="45000" anchor="ctr">
             <a:noAutofit/>
           </a:bodyPr>
           <a:p>
@@ -12130,7 +12132,7 @@
                 <a:uFillTx/>
                 <a:latin typeface="Calibri"/>
               </a:rPr>
-              <a:t>  Performance Metrics — Test Set  (n = 2,551)</a:t>
+              <a:t>  Performance Metrics — Test Set  (n = 2,614)</a:t>
             </a:r>
             <a:endParaRPr lang="en-US" sz="2800" b="0" u="none" strike="noStrike">
               <a:solidFill>
@@ -12145,7 +12147,7 @@
       </p:sp>
       <p:sp>
         <p:nvSpPr>
-          <p:cNvPr id="127" name="TextBox 3"/>
+          <p:cNvPr id="128" name="TextBox 3"/>
           <p:cNvSpPr/>
           <p:nvPr/>
         </p:nvSpPr>
@@ -12187,7 +12189,7 @@
                 <a:uFillTx/>
                 <a:latin typeface="Calibri"/>
               </a:rPr>
-              <a:t>  Metrics evaluated on held-out test set as required by Interim #2 brief</a:t>
+              <a:t>  Metrics on held-out, sequence-level test set as required by Interim #2 brief</a:t>
             </a:r>
             <a:endParaRPr lang="en-US" sz="1400" b="0" u="none" strike="noStrike">
               <a:solidFill>
@@ -12202,7 +12204,7 @@
       </p:sp>
       <p:sp>
         <p:nvSpPr>
-          <p:cNvPr id="128" name="Rectangle 4"/>
+          <p:cNvPr id="129" name="Rectangle 4"/>
           <p:cNvSpPr/>
           <p:nvPr/>
         </p:nvSpPr>
@@ -12258,7 +12260,7 @@
       </p:sp>
       <p:sp>
         <p:nvSpPr>
-          <p:cNvPr id="129" name="TextBox 5"/>
+          <p:cNvPr id="130" name="TextBox 5"/>
           <p:cNvSpPr/>
           <p:nvPr/>
         </p:nvSpPr>
@@ -12315,7 +12317,7 @@
       </p:sp>
       <p:sp>
         <p:nvSpPr>
-          <p:cNvPr id="130" name="TextBox 6"/>
+          <p:cNvPr id="131" name="TextBox 6"/>
           <p:cNvSpPr/>
           <p:nvPr/>
         </p:nvSpPr>
@@ -12357,7 +12359,7 @@
                 <a:uFillTx/>
                 <a:latin typeface="Calibri"/>
               </a:rPr>
-              <a:t>96.71%</a:t>
+              <a:t>96.44%</a:t>
             </a:r>
             <a:endParaRPr lang="en-US" sz="2200" b="0" u="none" strike="noStrike">
               <a:solidFill>
@@ -12372,7 +12374,7 @@
       </p:sp>
       <p:sp>
         <p:nvSpPr>
-          <p:cNvPr id="131" name="Rectangle 7"/>
+          <p:cNvPr id="132" name="Rectangle 7"/>
           <p:cNvSpPr/>
           <p:nvPr/>
         </p:nvSpPr>
@@ -12428,7 +12430,7 @@
       </p:sp>
       <p:sp>
         <p:nvSpPr>
-          <p:cNvPr id="132" name="TextBox 8"/>
+          <p:cNvPr id="133" name="TextBox 8"/>
           <p:cNvSpPr/>
           <p:nvPr/>
         </p:nvSpPr>
@@ -12470,18 +12472,7 @@
                 <a:uFillTx/>
                 <a:latin typeface="Calibri"/>
               </a:rPr>
-              <a:t>Macro F1-</a:t>
-            </a:r>
-            <a:r>
-              <a:rPr lang="en-US" sz="1200" b="0" u="none" strike="noStrike">
-                <a:solidFill>
-                  <a:srgbClr val="FFFFFF"/>
-                </a:solidFill>
-                <a:effectLst/>
-                <a:uFillTx/>
-                <a:latin typeface="Calibri"/>
-              </a:rPr>
-              <a:t>Score</a:t>
+              <a:t>Macro F1-Score</a:t>
             </a:r>
             <a:endParaRPr lang="en-US" sz="1200" b="0" u="none" strike="noStrike">
               <a:solidFill>
@@ -12496,7 +12487,7 @@
       </p:sp>
       <p:sp>
         <p:nvSpPr>
-          <p:cNvPr id="133" name="TextBox 9"/>
+          <p:cNvPr id="134" name="TextBox 9"/>
           <p:cNvSpPr/>
           <p:nvPr/>
         </p:nvSpPr>
@@ -12538,7 +12529,7 @@
                 <a:uFillTx/>
                 <a:latin typeface="Calibri"/>
               </a:rPr>
-              <a:t>96.88%</a:t>
+              <a:t>95.90%</a:t>
             </a:r>
             <a:endParaRPr lang="en-US" sz="2200" b="0" u="none" strike="noStrike">
               <a:solidFill>
@@ -12553,7 +12544,7 @@
       </p:sp>
       <p:sp>
         <p:nvSpPr>
-          <p:cNvPr id="134" name="Rectangle 10"/>
+          <p:cNvPr id="135" name="Rectangle 10"/>
           <p:cNvSpPr/>
           <p:nvPr/>
         </p:nvSpPr>
@@ -12609,7 +12600,7 @@
       </p:sp>
       <p:sp>
         <p:nvSpPr>
-          <p:cNvPr id="135" name="TextBox 11"/>
+          <p:cNvPr id="136" name="TextBox 11"/>
           <p:cNvSpPr/>
           <p:nvPr/>
         </p:nvSpPr>
@@ -12666,7 +12657,7 @@
       </p:sp>
       <p:sp>
         <p:nvSpPr>
-          <p:cNvPr id="136" name="TextBox 12"/>
+          <p:cNvPr id="137" name="TextBox 12"/>
           <p:cNvSpPr/>
           <p:nvPr/>
         </p:nvSpPr>
@@ -12708,7 +12699,7 @@
                 <a:uFillTx/>
                 <a:latin typeface="Calibri"/>
               </a:rPr>
-              <a:t>97.19%</a:t>
+              <a:t>95.69%</a:t>
             </a:r>
             <a:endParaRPr lang="en-US" sz="2200" b="0" u="none" strike="noStrike">
               <a:solidFill>
@@ -12723,7 +12714,7 @@
       </p:sp>
       <p:sp>
         <p:nvSpPr>
-          <p:cNvPr id="137" name="Rectangle 13"/>
+          <p:cNvPr id="138" name="Rectangle 13"/>
           <p:cNvSpPr/>
           <p:nvPr/>
         </p:nvSpPr>
@@ -12779,7 +12770,7 @@
       </p:sp>
       <p:sp>
         <p:nvSpPr>
-          <p:cNvPr id="138" name="TextBox 14"/>
+          <p:cNvPr id="139" name="TextBox 14"/>
           <p:cNvSpPr/>
           <p:nvPr/>
         </p:nvSpPr>
@@ -12836,7 +12827,7 @@
       </p:sp>
       <p:sp>
         <p:nvSpPr>
-          <p:cNvPr id="139" name="TextBox 15"/>
+          <p:cNvPr id="140" name="TextBox 15"/>
           <p:cNvSpPr/>
           <p:nvPr/>
         </p:nvSpPr>
@@ -12878,7 +12869,7 @@
                 <a:uFillTx/>
                 <a:latin typeface="Calibri"/>
               </a:rPr>
-              <a:t>96.60%</a:t>
+              <a:t>96.15%</a:t>
             </a:r>
             <a:endParaRPr lang="en-US" sz="2200" b="0" u="none" strike="noStrike">
               <a:solidFill>
@@ -12893,7 +12884,7 @@
       </p:sp>
       <p:sp>
         <p:nvSpPr>
-          <p:cNvPr id="140" name="Rectangle 16"/>
+          <p:cNvPr id="141" name="Rectangle 16"/>
           <p:cNvSpPr/>
           <p:nvPr/>
         </p:nvSpPr>
@@ -12949,7 +12940,7 @@
       </p:sp>
       <p:sp>
         <p:nvSpPr>
-          <p:cNvPr id="141" name="TextBox 17"/>
+          <p:cNvPr id="142" name="TextBox 17"/>
           <p:cNvSpPr/>
           <p:nvPr/>
         </p:nvSpPr>
@@ -13006,7 +12997,7 @@
       </p:sp>
       <p:sp>
         <p:nvSpPr>
-          <p:cNvPr id="142" name="TextBox 18"/>
+          <p:cNvPr id="143" name="TextBox 18"/>
           <p:cNvSpPr/>
           <p:nvPr/>
         </p:nvSpPr>
@@ -13048,7 +13039,7 @@
                 <a:uFillTx/>
                 <a:latin typeface="Calibri"/>
               </a:rPr>
-              <a:t>99.79%</a:t>
+              <a:t>99.59%</a:t>
             </a:r>
             <a:endParaRPr lang="en-US" sz="2200" b="0" u="none" strike="noStrike">
               <a:solidFill>
@@ -13063,7 +13054,7 @@
       </p:sp>
       <p:sp>
         <p:nvSpPr>
-          <p:cNvPr id="143" name="TextBox 19"/>
+          <p:cNvPr id="144" name="TextBox 19"/>
           <p:cNvSpPr/>
           <p:nvPr/>
         </p:nvSpPr>
@@ -13120,7 +13111,7 @@
       </p:sp>
       <p:sp>
         <p:nvSpPr>
-          <p:cNvPr id="144" name="Rectangle 20"/>
+          <p:cNvPr id="145" name="Rectangle 20"/>
           <p:cNvSpPr/>
           <p:nvPr/>
         </p:nvSpPr>
@@ -13176,7 +13167,7 @@
       </p:sp>
       <p:sp>
         <p:nvSpPr>
-          <p:cNvPr id="145" name="TextBox 21"/>
+          <p:cNvPr id="146" name="TextBox 21"/>
           <p:cNvSpPr/>
           <p:nvPr/>
         </p:nvSpPr>
@@ -13233,7 +13224,7 @@
       </p:sp>
       <p:sp>
         <p:nvSpPr>
-          <p:cNvPr id="146" name="Rectangle 22"/>
+          <p:cNvPr id="147" name="Rectangle 22"/>
           <p:cNvSpPr/>
           <p:nvPr/>
         </p:nvSpPr>
@@ -13289,7 +13280,7 @@
       </p:sp>
       <p:sp>
         <p:nvSpPr>
-          <p:cNvPr id="147" name="TextBox 23"/>
+          <p:cNvPr id="148" name="TextBox 23"/>
           <p:cNvSpPr/>
           <p:nvPr/>
         </p:nvSpPr>
@@ -13346,7 +13337,7 @@
       </p:sp>
       <p:sp>
         <p:nvSpPr>
-          <p:cNvPr id="148" name="Rectangle 24"/>
+          <p:cNvPr id="149" name="Rectangle 24"/>
           <p:cNvSpPr/>
           <p:nvPr/>
         </p:nvSpPr>
@@ -13402,7 +13393,7 @@
       </p:sp>
       <p:sp>
         <p:nvSpPr>
-          <p:cNvPr id="149" name="TextBox 25"/>
+          <p:cNvPr id="150" name="TextBox 25"/>
           <p:cNvSpPr/>
           <p:nvPr/>
         </p:nvSpPr>
@@ -13459,7 +13450,7 @@
       </p:sp>
       <p:sp>
         <p:nvSpPr>
-          <p:cNvPr id="150" name="Rectangle 26"/>
+          <p:cNvPr id="151" name="Rectangle 26"/>
           <p:cNvSpPr/>
           <p:nvPr/>
         </p:nvSpPr>
@@ -13515,7 +13506,7 @@
       </p:sp>
       <p:sp>
         <p:nvSpPr>
-          <p:cNvPr id="151" name="TextBox 27"/>
+          <p:cNvPr id="152" name="TextBox 27"/>
           <p:cNvSpPr/>
           <p:nvPr/>
         </p:nvSpPr>
@@ -13572,7 +13563,7 @@
       </p:sp>
       <p:sp>
         <p:nvSpPr>
-          <p:cNvPr id="152" name="Rectangle 28"/>
+          <p:cNvPr id="153" name="Rectangle 28"/>
           <p:cNvSpPr/>
           <p:nvPr/>
         </p:nvSpPr>
@@ -13628,7 +13619,7 @@
       </p:sp>
       <p:sp>
         <p:nvSpPr>
-          <p:cNvPr id="153" name="TextBox 29"/>
+          <p:cNvPr id="154" name="TextBox 29"/>
           <p:cNvSpPr/>
           <p:nvPr/>
         </p:nvSpPr>
@@ -13685,7 +13676,7 @@
       </p:sp>
       <p:sp>
         <p:nvSpPr>
-          <p:cNvPr id="154" name="Rectangle 30"/>
+          <p:cNvPr id="155" name="Rectangle 30"/>
           <p:cNvSpPr/>
           <p:nvPr/>
         </p:nvSpPr>
@@ -13741,7 +13732,7 @@
       </p:sp>
       <p:sp>
         <p:nvSpPr>
-          <p:cNvPr id="155" name="TextBox 31"/>
+          <p:cNvPr id="156" name="TextBox 31"/>
           <p:cNvSpPr/>
           <p:nvPr/>
         </p:nvSpPr>
@@ -13798,7 +13789,7 @@
       </p:sp>
       <p:sp>
         <p:nvSpPr>
-          <p:cNvPr id="156" name="Rectangle 32"/>
+          <p:cNvPr id="157" name="Rectangle 32"/>
           <p:cNvSpPr/>
           <p:nvPr/>
         </p:nvSpPr>
@@ -13857,7 +13848,7 @@
       </p:sp>
       <p:sp>
         <p:nvSpPr>
-          <p:cNvPr id="157" name="TextBox 33"/>
+          <p:cNvPr id="158" name="TextBox 33"/>
           <p:cNvSpPr/>
           <p:nvPr/>
         </p:nvSpPr>
@@ -13914,7 +13905,7 @@
       </p:sp>
       <p:sp>
         <p:nvSpPr>
-          <p:cNvPr id="158" name="Rectangle 34"/>
+          <p:cNvPr id="159" name="Rectangle 34"/>
           <p:cNvSpPr/>
           <p:nvPr/>
         </p:nvSpPr>
@@ -13973,7 +13964,7 @@
       </p:sp>
       <p:sp>
         <p:nvSpPr>
-          <p:cNvPr id="159" name="TextBox 35"/>
+          <p:cNvPr id="160" name="TextBox 35"/>
           <p:cNvSpPr/>
           <p:nvPr/>
         </p:nvSpPr>
@@ -14015,7 +14006,7 @@
                 <a:uFillTx/>
                 <a:latin typeface="Calibri"/>
               </a:rPr>
-              <a:t>93.61%</a:t>
+              <a:t>96.04%</a:t>
             </a:r>
             <a:endParaRPr lang="en-US" sz="1300" b="0" u="none" strike="noStrike">
               <a:solidFill>
@@ -14030,7 +14021,7 @@
       </p:sp>
       <p:sp>
         <p:nvSpPr>
-          <p:cNvPr id="160" name="Rectangle 36"/>
+          <p:cNvPr id="161" name="Rectangle 36"/>
           <p:cNvSpPr/>
           <p:nvPr/>
         </p:nvSpPr>
@@ -14089,7 +14080,7 @@
       </p:sp>
       <p:sp>
         <p:nvSpPr>
-          <p:cNvPr id="161" name="TextBox 37"/>
+          <p:cNvPr id="162" name="TextBox 37"/>
           <p:cNvSpPr/>
           <p:nvPr/>
         </p:nvSpPr>
@@ -14131,7 +14122,7 @@
                 <a:uFillTx/>
                 <a:latin typeface="Calibri"/>
               </a:rPr>
-              <a:t>97.60%</a:t>
+              <a:t>92.92%</a:t>
             </a:r>
             <a:endParaRPr lang="en-US" sz="1300" b="0" u="none" strike="noStrike">
               <a:solidFill>
@@ -14146,7 +14137,7 @@
       </p:sp>
       <p:sp>
         <p:nvSpPr>
-          <p:cNvPr id="162" name="Rectangle 38"/>
+          <p:cNvPr id="163" name="Rectangle 38"/>
           <p:cNvSpPr/>
           <p:nvPr/>
         </p:nvSpPr>
@@ -14205,7 +14196,7 @@
       </p:sp>
       <p:sp>
         <p:nvSpPr>
-          <p:cNvPr id="163" name="TextBox 39"/>
+          <p:cNvPr id="164" name="TextBox 39"/>
           <p:cNvSpPr/>
           <p:nvPr/>
         </p:nvSpPr>
@@ -14247,7 +14238,7 @@
                 <a:uFillTx/>
                 <a:latin typeface="Calibri"/>
               </a:rPr>
-              <a:t>97.22%</a:t>
+              <a:t>99.20%</a:t>
             </a:r>
             <a:endParaRPr lang="en-US" sz="1300" b="0" u="none" strike="noStrike">
               <a:solidFill>
@@ -14262,7 +14253,7 @@
       </p:sp>
       <p:sp>
         <p:nvSpPr>
-          <p:cNvPr id="164" name="Rectangle 40"/>
+          <p:cNvPr id="165" name="Rectangle 40"/>
           <p:cNvSpPr/>
           <p:nvPr/>
         </p:nvSpPr>
@@ -14321,7 +14312,7 @@
       </p:sp>
       <p:sp>
         <p:nvSpPr>
-          <p:cNvPr id="165" name="TextBox 41"/>
+          <p:cNvPr id="166" name="TextBox 41"/>
           <p:cNvSpPr/>
           <p:nvPr/>
         </p:nvSpPr>
@@ -14363,7 +14354,7 @@
                 <a:uFillTx/>
                 <a:latin typeface="Calibri"/>
               </a:rPr>
-              <a:t>95.56%</a:t>
+              <a:t>94.45%</a:t>
             </a:r>
             <a:endParaRPr lang="en-US" sz="1300" b="0" u="none" strike="noStrike">
               <a:solidFill>
@@ -14378,7 +14369,7 @@
       </p:sp>
       <p:sp>
         <p:nvSpPr>
-          <p:cNvPr id="166" name="Rectangle 42"/>
+          <p:cNvPr id="167" name="Rectangle 42"/>
           <p:cNvSpPr/>
           <p:nvPr/>
         </p:nvSpPr>
@@ -14437,7 +14428,7 @@
       </p:sp>
       <p:sp>
         <p:nvSpPr>
-          <p:cNvPr id="167" name="TextBox 43"/>
+          <p:cNvPr id="168" name="TextBox 43"/>
           <p:cNvSpPr/>
           <p:nvPr/>
         </p:nvSpPr>
@@ -14479,7 +14470,7 @@
                 <a:uFillTx/>
                 <a:latin typeface="Calibri"/>
               </a:rPr>
-              <a:t>750</a:t>
+              <a:t>438</a:t>
             </a:r>
             <a:endParaRPr lang="en-US" sz="1300" b="0" u="none" strike="noStrike">
               <a:solidFill>
@@ -14494,7 +14485,7 @@
       </p:sp>
       <p:sp>
         <p:nvSpPr>
-          <p:cNvPr id="168" name="Rectangle 44"/>
+          <p:cNvPr id="169" name="Rectangle 44"/>
           <p:cNvSpPr/>
           <p:nvPr/>
         </p:nvSpPr>
@@ -14553,7 +14544,7 @@
       </p:sp>
       <p:sp>
         <p:nvSpPr>
-          <p:cNvPr id="169" name="TextBox 45"/>
+          <p:cNvPr id="170" name="TextBox 45"/>
           <p:cNvSpPr/>
           <p:nvPr/>
         </p:nvSpPr>
@@ -14610,7 +14601,7 @@
       </p:sp>
       <p:sp>
         <p:nvSpPr>
-          <p:cNvPr id="170" name="Rectangle 46"/>
+          <p:cNvPr id="171" name="Rectangle 46"/>
           <p:cNvSpPr/>
           <p:nvPr/>
         </p:nvSpPr>
@@ -14669,7 +14660,7 @@
       </p:sp>
       <p:sp>
         <p:nvSpPr>
-          <p:cNvPr id="171" name="TextBox 47"/>
+          <p:cNvPr id="172" name="TextBox 47"/>
           <p:cNvSpPr/>
           <p:nvPr/>
         </p:nvSpPr>
@@ -14711,7 +14702,7 @@
                 <a:uFillTx/>
                 <a:latin typeface="Calibri"/>
               </a:rPr>
-              <a:t>99.60%</a:t>
+              <a:t>99.16%</a:t>
             </a:r>
             <a:endParaRPr lang="en-US" sz="1300" b="0" u="none" strike="noStrike">
               <a:solidFill>
@@ -14726,7 +14717,7 @@
       </p:sp>
       <p:sp>
         <p:nvSpPr>
-          <p:cNvPr id="172" name="Rectangle 48"/>
+          <p:cNvPr id="173" name="Rectangle 48"/>
           <p:cNvSpPr/>
           <p:nvPr/>
         </p:nvSpPr>
@@ -14785,7 +14776,7 @@
       </p:sp>
       <p:sp>
         <p:nvSpPr>
-          <p:cNvPr id="173" name="TextBox 49"/>
+          <p:cNvPr id="174" name="TextBox 49"/>
           <p:cNvSpPr/>
           <p:nvPr/>
         </p:nvSpPr>
@@ -14827,7 +14818,7 @@
                 <a:uFillTx/>
                 <a:latin typeface="Calibri"/>
               </a:rPr>
-              <a:t>98.93%</a:t>
+              <a:t>97.45%</a:t>
             </a:r>
             <a:endParaRPr lang="en-US" sz="1300" b="0" u="none" strike="noStrike">
               <a:solidFill>
@@ -14842,7 +14833,7 @@
       </p:sp>
       <p:sp>
         <p:nvSpPr>
-          <p:cNvPr id="174" name="Rectangle 50"/>
+          <p:cNvPr id="175" name="Rectangle 50"/>
           <p:cNvSpPr/>
           <p:nvPr/>
         </p:nvSpPr>
@@ -14901,7 +14892,7 @@
       </p:sp>
       <p:sp>
         <p:nvSpPr>
-          <p:cNvPr id="175" name="TextBox 51"/>
+          <p:cNvPr id="176" name="TextBox 51"/>
           <p:cNvSpPr/>
           <p:nvPr/>
         </p:nvSpPr>
@@ -14943,7 +14934,7 @@
                 <a:uFillTx/>
                 <a:latin typeface="Calibri"/>
               </a:rPr>
-              <a:t>99.83%</a:t>
+              <a:t>99.39%</a:t>
             </a:r>
             <a:endParaRPr lang="en-US" sz="1300" b="0" u="none" strike="noStrike">
               <a:solidFill>
@@ -14958,7 +14949,7 @@
       </p:sp>
       <p:sp>
         <p:nvSpPr>
-          <p:cNvPr id="176" name="Rectangle 52"/>
+          <p:cNvPr id="177" name="Rectangle 52"/>
           <p:cNvSpPr/>
           <p:nvPr/>
         </p:nvSpPr>
@@ -15017,7 +15008,7 @@
       </p:sp>
       <p:sp>
         <p:nvSpPr>
-          <p:cNvPr id="177" name="TextBox 53"/>
+          <p:cNvPr id="178" name="TextBox 53"/>
           <p:cNvSpPr/>
           <p:nvPr/>
         </p:nvSpPr>
@@ -15059,7 +15050,7 @@
                 <a:uFillTx/>
                 <a:latin typeface="Calibri"/>
               </a:rPr>
-              <a:t>99.26%</a:t>
+              <a:t>98.30%</a:t>
             </a:r>
             <a:endParaRPr lang="en-US" sz="1300" b="0" u="none" strike="noStrike">
               <a:solidFill>
@@ -15074,7 +15065,7 @@
       </p:sp>
       <p:sp>
         <p:nvSpPr>
-          <p:cNvPr id="178" name="Rectangle 54"/>
+          <p:cNvPr id="179" name="Rectangle 54"/>
           <p:cNvSpPr/>
           <p:nvPr/>
         </p:nvSpPr>
@@ -15133,7 +15124,7 @@
       </p:sp>
       <p:sp>
         <p:nvSpPr>
-          <p:cNvPr id="179" name="TextBox 55"/>
+          <p:cNvPr id="180" name="TextBox 55"/>
           <p:cNvSpPr/>
           <p:nvPr/>
         </p:nvSpPr>
@@ -15175,7 +15166,7 @@
                 <a:uFillTx/>
                 <a:latin typeface="Calibri"/>
               </a:rPr>
-              <a:t>750</a:t>
+              <a:t>1,136</a:t>
             </a:r>
             <a:endParaRPr lang="en-US" sz="1300" b="0" u="none" strike="noStrike">
               <a:solidFill>
@@ -15190,7 +15181,7 @@
       </p:sp>
       <p:sp>
         <p:nvSpPr>
-          <p:cNvPr id="180" name="Rectangle 56"/>
+          <p:cNvPr id="181" name="Rectangle 56"/>
           <p:cNvSpPr/>
           <p:nvPr/>
         </p:nvSpPr>
@@ -15249,7 +15240,7 @@
       </p:sp>
       <p:sp>
         <p:nvSpPr>
-          <p:cNvPr id="181" name="TextBox 57"/>
+          <p:cNvPr id="182" name="TextBox 57"/>
           <p:cNvSpPr/>
           <p:nvPr/>
         </p:nvSpPr>
@@ -15306,7 +15297,7 @@
       </p:sp>
       <p:sp>
         <p:nvSpPr>
-          <p:cNvPr id="182" name="Rectangle 58"/>
+          <p:cNvPr id="183" name="Rectangle 58"/>
           <p:cNvSpPr/>
           <p:nvPr/>
         </p:nvSpPr>
@@ -15365,7 +15356,7 @@
       </p:sp>
       <p:sp>
         <p:nvSpPr>
-          <p:cNvPr id="183" name="TextBox 59"/>
+          <p:cNvPr id="184" name="TextBox 59"/>
           <p:cNvSpPr/>
           <p:nvPr/>
         </p:nvSpPr>
@@ -15407,7 +15398,7 @@
                 <a:uFillTx/>
                 <a:latin typeface="Calibri"/>
               </a:rPr>
-              <a:t>95.92%</a:t>
+              <a:t>93.69%</a:t>
             </a:r>
             <a:endParaRPr lang="en-US" sz="1300" b="0" u="none" strike="noStrike">
               <a:solidFill>
@@ -15422,7 +15413,7 @@
       </p:sp>
       <p:sp>
         <p:nvSpPr>
-          <p:cNvPr id="184" name="Rectangle 60"/>
+          <p:cNvPr id="185" name="Rectangle 60"/>
           <p:cNvSpPr/>
           <p:nvPr/>
         </p:nvSpPr>
@@ -15481,7 +15472,7 @@
       </p:sp>
       <p:sp>
         <p:nvSpPr>
-          <p:cNvPr id="185" name="TextBox 61"/>
+          <p:cNvPr id="186" name="TextBox 61"/>
           <p:cNvSpPr/>
           <p:nvPr/>
         </p:nvSpPr>
@@ -15523,7 +15514,7 @@
                 <a:uFillTx/>
                 <a:latin typeface="Calibri"/>
               </a:rPr>
-              <a:t>93.87%</a:t>
+              <a:t>96.26%</a:t>
             </a:r>
             <a:endParaRPr lang="en-US" sz="1300" b="0" u="none" strike="noStrike">
               <a:solidFill>
@@ -15538,7 +15529,7 @@
       </p:sp>
       <p:sp>
         <p:nvSpPr>
-          <p:cNvPr id="186" name="Rectangle 62"/>
+          <p:cNvPr id="187" name="Rectangle 62"/>
           <p:cNvSpPr/>
           <p:nvPr/>
         </p:nvSpPr>
@@ -15597,7 +15588,7 @@
       </p:sp>
       <p:sp>
         <p:nvSpPr>
-          <p:cNvPr id="187" name="TextBox 63"/>
+          <p:cNvPr id="188" name="TextBox 63"/>
           <p:cNvSpPr/>
           <p:nvPr/>
         </p:nvSpPr>
@@ -15639,7 +15630,7 @@
                 <a:uFillTx/>
                 <a:latin typeface="Calibri"/>
               </a:rPr>
-              <a:t>98.33%</a:t>
+              <a:t>97.71%</a:t>
             </a:r>
             <a:endParaRPr lang="en-US" sz="1300" b="0" u="none" strike="noStrike">
               <a:solidFill>
@@ -15654,7 +15645,7 @@
       </p:sp>
       <p:sp>
         <p:nvSpPr>
-          <p:cNvPr id="188" name="Rectangle 64"/>
+          <p:cNvPr id="189" name="Rectangle 64"/>
           <p:cNvSpPr/>
           <p:nvPr/>
         </p:nvSpPr>
@@ -15713,7 +15704,7 @@
       </p:sp>
       <p:sp>
         <p:nvSpPr>
-          <p:cNvPr id="189" name="TextBox 65"/>
+          <p:cNvPr id="190" name="TextBox 65"/>
           <p:cNvSpPr/>
           <p:nvPr/>
         </p:nvSpPr>
@@ -15755,7 +15746,7 @@
                 <a:uFillTx/>
                 <a:latin typeface="Calibri"/>
               </a:rPr>
-              <a:t>94.89%</a:t>
+              <a:t>94.96%</a:t>
             </a:r>
             <a:endParaRPr lang="en-US" sz="1300" b="0" u="none" strike="noStrike">
               <a:solidFill>
@@ -15770,7 +15761,7 @@
       </p:sp>
       <p:sp>
         <p:nvSpPr>
-          <p:cNvPr id="190" name="Rectangle 66"/>
+          <p:cNvPr id="191" name="Rectangle 66"/>
           <p:cNvSpPr/>
           <p:nvPr/>
         </p:nvSpPr>
@@ -15829,7 +15820,7 @@
       </p:sp>
       <p:sp>
         <p:nvSpPr>
-          <p:cNvPr id="191" name="TextBox 67"/>
+          <p:cNvPr id="192" name="TextBox 67"/>
           <p:cNvSpPr/>
           <p:nvPr/>
         </p:nvSpPr>
@@ -15871,7 +15862,7 @@
                 <a:uFillTx/>
                 <a:latin typeface="Calibri"/>
               </a:rPr>
-              <a:t>751</a:t>
+              <a:t>695</a:t>
             </a:r>
             <a:endParaRPr lang="en-US" sz="1300" b="0" u="none" strike="noStrike">
               <a:solidFill>
@@ -15886,7 +15877,7 @@
       </p:sp>
       <p:sp>
         <p:nvSpPr>
-          <p:cNvPr id="192" name="Rectangle 68"/>
+          <p:cNvPr id="193" name="Rectangle 68"/>
           <p:cNvSpPr/>
           <p:nvPr/>
         </p:nvSpPr>
@@ -15945,7 +15936,7 @@
       </p:sp>
       <p:sp>
         <p:nvSpPr>
-          <p:cNvPr id="193" name="TextBox 69"/>
+          <p:cNvPr id="194" name="TextBox 69"/>
           <p:cNvSpPr/>
           <p:nvPr/>
         </p:nvSpPr>
@@ -16002,7 +15993,7 @@
       </p:sp>
       <p:sp>
         <p:nvSpPr>
-          <p:cNvPr id="194" name="Rectangle 70"/>
+          <p:cNvPr id="195" name="Rectangle 70"/>
           <p:cNvSpPr/>
           <p:nvPr/>
         </p:nvSpPr>
@@ -16061,7 +16052,7 @@
       </p:sp>
       <p:sp>
         <p:nvSpPr>
-          <p:cNvPr id="195" name="TextBox 71"/>
+          <p:cNvPr id="196" name="TextBox 71"/>
           <p:cNvSpPr/>
           <p:nvPr/>
         </p:nvSpPr>
@@ -16103,7 +16094,7 @@
                 <a:uFillTx/>
                 <a:latin typeface="Calibri"/>
               </a:rPr>
-              <a:t>99.65%</a:t>
+              <a:t>93.86%</a:t>
             </a:r>
             <a:endParaRPr lang="en-US" sz="1300" b="0" u="none" strike="noStrike">
               <a:solidFill>
@@ -16118,7 +16109,7 @@
       </p:sp>
       <p:sp>
         <p:nvSpPr>
-          <p:cNvPr id="196" name="Rectangle 72"/>
+          <p:cNvPr id="197" name="Rectangle 72"/>
           <p:cNvSpPr/>
           <p:nvPr/>
         </p:nvSpPr>
@@ -16177,7 +16168,7 @@
       </p:sp>
       <p:sp>
         <p:nvSpPr>
-          <p:cNvPr id="197" name="TextBox 73"/>
+          <p:cNvPr id="198" name="TextBox 73"/>
           <p:cNvSpPr/>
           <p:nvPr/>
         </p:nvSpPr>
@@ -16219,7 +16210,7 @@
                 <a:uFillTx/>
                 <a:latin typeface="Calibri"/>
               </a:rPr>
-              <a:t>96.00%</a:t>
+              <a:t>97.97%</a:t>
             </a:r>
             <a:endParaRPr lang="en-US" sz="1300" b="0" u="none" strike="noStrike">
               <a:solidFill>
@@ -16234,7 +16225,7 @@
       </p:sp>
       <p:sp>
         <p:nvSpPr>
-          <p:cNvPr id="198" name="Rectangle 74"/>
+          <p:cNvPr id="199" name="Rectangle 74"/>
           <p:cNvSpPr/>
           <p:nvPr/>
         </p:nvSpPr>
@@ -16293,7 +16284,7 @@
       </p:sp>
       <p:sp>
         <p:nvSpPr>
-          <p:cNvPr id="199" name="TextBox 75"/>
+          <p:cNvPr id="200" name="TextBox 75"/>
           <p:cNvSpPr/>
           <p:nvPr/>
         </p:nvSpPr>
@@ -16335,7 +16326,7 @@
                 <a:uFillTx/>
                 <a:latin typeface="Calibri"/>
               </a:rPr>
-              <a:t>99.96%</a:t>
+              <a:t>99.03%</a:t>
             </a:r>
             <a:endParaRPr lang="en-US" sz="1300" b="0" u="none" strike="noStrike">
               <a:solidFill>
@@ -16350,7 +16341,7 @@
       </p:sp>
       <p:sp>
         <p:nvSpPr>
-          <p:cNvPr id="200" name="Rectangle 76"/>
+          <p:cNvPr id="201" name="Rectangle 76"/>
           <p:cNvSpPr/>
           <p:nvPr/>
         </p:nvSpPr>
@@ -16409,7 +16400,7 @@
       </p:sp>
       <p:sp>
         <p:nvSpPr>
-          <p:cNvPr id="201" name="TextBox 77"/>
+          <p:cNvPr id="202" name="TextBox 77"/>
           <p:cNvSpPr/>
           <p:nvPr/>
         </p:nvSpPr>
@@ -16451,7 +16442,7 @@
                 <a:uFillTx/>
                 <a:latin typeface="Calibri"/>
               </a:rPr>
-              <a:t>97.79%</a:t>
+              <a:t>95.87%</a:t>
             </a:r>
             <a:endParaRPr lang="en-US" sz="1300" b="0" u="none" strike="noStrike">
               <a:solidFill>
@@ -16466,7 +16457,7 @@
       </p:sp>
       <p:sp>
         <p:nvSpPr>
-          <p:cNvPr id="202" name="Rectangle 78"/>
+          <p:cNvPr id="203" name="Rectangle 78"/>
           <p:cNvSpPr/>
           <p:nvPr/>
         </p:nvSpPr>
@@ -16525,7 +16516,7 @@
       </p:sp>
       <p:sp>
         <p:nvSpPr>
-          <p:cNvPr id="203" name="TextBox 79"/>
+          <p:cNvPr id="204" name="TextBox 79"/>
           <p:cNvSpPr/>
           <p:nvPr/>
         </p:nvSpPr>
@@ -16567,7 +16558,7 @@
                 <a:uFillTx/>
                 <a:latin typeface="Calibri"/>
               </a:rPr>
-              <a:t>300</a:t>
+              <a:t>345</a:t>
             </a:r>
             <a:endParaRPr lang="en-US" sz="1300" b="0" u="none" strike="noStrike">
               <a:solidFill>
@@ -16582,7 +16573,7 @@
       </p:sp>
       <p:sp>
         <p:nvSpPr>
-          <p:cNvPr id="204" name="TextBox 80"/>
+          <p:cNvPr id="205" name="TextBox 80"/>
           <p:cNvSpPr/>
           <p:nvPr/>
         </p:nvSpPr>
@@ -16639,7 +16630,7 @@
       </p:sp>
       <p:sp>
         <p:nvSpPr>
-          <p:cNvPr id="205" name="Rectangle 81"/>
+          <p:cNvPr id="206" name="Rectangle 81"/>
           <p:cNvSpPr/>
           <p:nvPr/>
         </p:nvSpPr>
@@ -16725,7 +16716,7 @@
       </p:grpSpPr>
       <p:sp>
         <p:nvSpPr>
-          <p:cNvPr id="206" name="Rectangle 1"/>
+          <p:cNvPr id="207" name="Rectangle 1"/>
           <p:cNvSpPr/>
           <p:nvPr/>
         </p:nvSpPr>
@@ -16781,7 +16772,7 @@
       </p:sp>
       <p:sp>
         <p:nvSpPr>
-          <p:cNvPr id="207" name="Rectangle 2"/>
+          <p:cNvPr id="208" name="Rectangle 2"/>
           <p:cNvSpPr/>
           <p:nvPr/>
         </p:nvSpPr>
@@ -16820,7 +16811,7 @@
           <a:fontRef idx="minor"/>
         </p:style>
         <p:txBody>
-          <a:bodyPr wrap="none" lIns="90000" tIns="45000" rIns="90000" bIns="45000" anchor="ctr">
+          <a:bodyPr lIns="90000" tIns="45000" rIns="90000" bIns="45000" anchor="ctr">
             <a:noAutofit/>
           </a:bodyPr>
           <a:p>
@@ -16853,7 +16844,7 @@
       </p:sp>
       <p:sp>
         <p:nvSpPr>
-          <p:cNvPr id="208" name="TextBox 3"/>
+          <p:cNvPr id="209" name="TextBox 3"/>
           <p:cNvSpPr/>
           <p:nvPr/>
         </p:nvSpPr>
@@ -16910,7 +16901,7 @@
       </p:sp>
       <p:pic>
         <p:nvPicPr>
-          <p:cNvPr id="209" name="Picture 4" descr="training_curves.png"/>
+          <p:cNvPr id="210" name="Picture 4" descr="training_curves.png"/>
           <p:cNvPicPr/>
           <p:nvPr/>
         </p:nvPicPr>
@@ -16920,7 +16911,7 @@
         </p:blipFill>
         <p:spPr>
           <a:xfrm>
-            <a:off x="228600" y="1371960"/>
+            <a:off x="228600" y="1325880"/>
             <a:ext cx="5668920" cy="2285640"/>
           </a:xfrm>
           <a:prstGeom prst="rect">
@@ -16934,7 +16925,7 @@
       </p:pic>
       <p:sp>
         <p:nvSpPr>
-          <p:cNvPr id="210" name="TextBox 5"/>
+          <p:cNvPr id="211" name="TextBox 5"/>
           <p:cNvSpPr/>
           <p:nvPr/>
         </p:nvSpPr>
@@ -16991,7 +16982,7 @@
       </p:sp>
       <p:pic>
         <p:nvPicPr>
-          <p:cNvPr id="211" name="Picture 6" descr="confusion_matrix.png"/>
+          <p:cNvPr id="212" name="Picture 6" descr="confusion_matrix.png"/>
           <p:cNvPicPr/>
           <p:nvPr/>
         </p:nvPicPr>
@@ -17015,13 +17006,13 @@
       </p:pic>
       <p:sp>
         <p:nvSpPr>
-          <p:cNvPr id="212" name="TextBox 7"/>
+          <p:cNvPr id="213" name="TextBox 7"/>
           <p:cNvSpPr/>
           <p:nvPr/>
         </p:nvSpPr>
         <p:spPr>
           <a:xfrm>
-            <a:off x="228600" y="3649320"/>
+            <a:off x="228600" y="3538800"/>
             <a:ext cx="5668920" cy="237240"/>
           </a:xfrm>
           <a:prstGeom prst="rect">
@@ -17072,7 +17063,7 @@
       </p:sp>
       <p:pic>
         <p:nvPicPr>
-          <p:cNvPr id="213" name="Picture 8" descr="roc_curves.png"/>
+          <p:cNvPr id="214" name="Picture 8" descr="roc_curves.png"/>
           <p:cNvPicPr/>
           <p:nvPr/>
         </p:nvPicPr>
@@ -17082,7 +17073,7 @@
         </p:blipFill>
         <p:spPr>
           <a:xfrm>
-            <a:off x="228600" y="3886560"/>
+            <a:off x="228600" y="3794760"/>
             <a:ext cx="5668920" cy="2285640"/>
           </a:xfrm>
           <a:prstGeom prst="rect">
@@ -17096,13 +17087,13 @@
       </p:pic>
       <p:sp>
         <p:nvSpPr>
-          <p:cNvPr id="214" name="TextBox 9"/>
+          <p:cNvPr id="215" name="TextBox 9"/>
           <p:cNvSpPr/>
           <p:nvPr/>
         </p:nvSpPr>
         <p:spPr>
           <a:xfrm>
-            <a:off x="6263640" y="3649320"/>
+            <a:off x="6263640" y="3538800"/>
             <a:ext cx="5668920" cy="237240"/>
           </a:xfrm>
           <a:prstGeom prst="rect">
@@ -17153,7 +17144,7 @@
       </p:sp>
       <p:pic>
         <p:nvPicPr>
-          <p:cNvPr id="215" name="Picture 10" descr="per_class_f1.png"/>
+          <p:cNvPr id="216" name="Picture 10" descr="per_class_f1.png"/>
           <p:cNvPicPr/>
           <p:nvPr/>
         </p:nvPicPr>
@@ -17163,7 +17154,7 @@
         </p:blipFill>
         <p:spPr>
           <a:xfrm>
-            <a:off x="6263640" y="3886560"/>
+            <a:off x="6263640" y="3794760"/>
             <a:ext cx="5668920" cy="2285640"/>
           </a:xfrm>
           <a:prstGeom prst="rect">
@@ -17177,7 +17168,7 @@
       </p:pic>
       <p:sp>
         <p:nvSpPr>
-          <p:cNvPr id="216" name="TextBox 11"/>
+          <p:cNvPr id="217" name="TextBox 11"/>
           <p:cNvSpPr/>
           <p:nvPr/>
         </p:nvSpPr>
@@ -17234,7 +17225,7 @@
       </p:sp>
       <p:sp>
         <p:nvSpPr>
-          <p:cNvPr id="217" name="Rectangle 12"/>
+          <p:cNvPr id="218" name="Rectangle 12"/>
           <p:cNvSpPr/>
           <p:nvPr/>
         </p:nvSpPr>
@@ -17320,7 +17311,7 @@
       </p:grpSpPr>
       <p:sp>
         <p:nvSpPr>
-          <p:cNvPr id="218" name="Rectangle 1"/>
+          <p:cNvPr id="219" name="Rectangle 1"/>
           <p:cNvSpPr/>
           <p:nvPr/>
         </p:nvSpPr>
@@ -17376,7 +17367,7 @@
       </p:sp>
       <p:sp>
         <p:nvSpPr>
-          <p:cNvPr id="219" name="Rectangle 2"/>
+          <p:cNvPr id="220" name="Rectangle 2"/>
           <p:cNvSpPr/>
           <p:nvPr/>
         </p:nvSpPr>
@@ -17415,7 +17406,7 @@
           <a:fontRef idx="minor"/>
         </p:style>
         <p:txBody>
-          <a:bodyPr wrap="none" lIns="90000" tIns="45000" rIns="90000" bIns="45000" anchor="ctr">
+          <a:bodyPr lIns="90000" tIns="45000" rIns="90000" bIns="45000" anchor="ctr">
             <a:noAutofit/>
           </a:bodyPr>
           <a:p>
@@ -17448,7 +17439,7 @@
       </p:sp>
       <p:sp>
         <p:nvSpPr>
-          <p:cNvPr id="220" name="Rectangle 3"/>
+          <p:cNvPr id="221" name="Rectangle 3"/>
           <p:cNvSpPr/>
           <p:nvPr/>
         </p:nvSpPr>
@@ -17507,7 +17498,7 @@
       </p:sp>
       <p:sp>
         <p:nvSpPr>
-          <p:cNvPr id="221" name="TextBox 4"/>
+          <p:cNvPr id="222" name="TextBox 4"/>
           <p:cNvSpPr/>
           <p:nvPr/>
         </p:nvSpPr>
@@ -17549,7 +17540,7 @@
                 <a:uFillTx/>
                 <a:latin typeface="Calibri"/>
               </a:rPr>
-              <a:t>Challenge: MobileViT is a patch classifier (trained on cropped objects). Applying it directly to full-resolution video frames yields poor localisation.</a:t>
+              <a:t>Challenge: MobileViT is a patch classifier (trained on cropped objects). Applied directly to full-resolution frames it has poor localisation.</a:t>
             </a:r>
             <a:endParaRPr lang="en-US" sz="1300" b="0" u="none" strike="noStrike">
               <a:solidFill>
@@ -17564,7 +17555,7 @@
       </p:sp>
       <p:sp>
         <p:nvSpPr>
-          <p:cNvPr id="222" name="Rectangle 5"/>
+          <p:cNvPr id="223" name="Rectangle 5"/>
           <p:cNvSpPr/>
           <p:nvPr/>
         </p:nvSpPr>
@@ -17620,7 +17611,7 @@
       </p:sp>
       <p:sp>
         <p:nvSpPr>
-          <p:cNvPr id="223" name="TextBox 6"/>
+          <p:cNvPr id="224" name="TextBox 6"/>
           <p:cNvSpPr/>
           <p:nvPr/>
         </p:nvSpPr>
@@ -17677,7 +17668,7 @@
       </p:sp>
       <p:sp>
         <p:nvSpPr>
-          <p:cNvPr id="224" name="TextBox 7"/>
+          <p:cNvPr id="225" name="TextBox 7"/>
           <p:cNvSpPr/>
           <p:nvPr/>
         </p:nvSpPr>
@@ -17719,7 +17710,7 @@
                 <a:uFillTx/>
                 <a:latin typeface="Calibri"/>
               </a:rPr>
-              <a:t>Video decoded frame-by-frame at 5 fps using OpenCV.</a:t>
+              <a:t>Video decoded frame-by-frame using OpenCV (with frame_skip).</a:t>
             </a:r>
             <a:endParaRPr lang="en-US" sz="1200" b="0" u="none" strike="noStrike">
               <a:solidFill>
@@ -17734,7 +17725,7 @@
       </p:sp>
       <p:sp>
         <p:nvSpPr>
-          <p:cNvPr id="225" name="Rectangle 8"/>
+          <p:cNvPr id="226" name="Rectangle 8"/>
           <p:cNvSpPr/>
           <p:nvPr/>
         </p:nvSpPr>
@@ -17790,7 +17781,7 @@
       </p:sp>
       <p:sp>
         <p:nvSpPr>
-          <p:cNvPr id="226" name="TextBox 9"/>
+          <p:cNvPr id="227" name="TextBox 9"/>
           <p:cNvSpPr/>
           <p:nvPr/>
         </p:nvSpPr>
@@ -17847,7 +17838,7 @@
       </p:sp>
       <p:sp>
         <p:nvSpPr>
-          <p:cNvPr id="227" name="TextBox 10"/>
+          <p:cNvPr id="228" name="TextBox 10"/>
           <p:cNvSpPr/>
           <p:nvPr/>
         </p:nvSpPr>
@@ -17889,7 +17880,7 @@
                 <a:uFillTx/>
                 <a:latin typeface="Calibri"/>
               </a:rPr>
-              <a:t>Windows of 3 sizes (128, 192, 256 px) stride across each frame. Each patch is resized to 224 × 224 and fed to the MobileViT classifier.</a:t>
+              <a:t>Windows of 3 sizes (120, 180, 256 px) stride across each frame; each patch resized to 256×256 for MobileViT.</a:t>
             </a:r>
             <a:endParaRPr lang="en-US" sz="1200" b="0" u="none" strike="noStrike">
               <a:solidFill>
@@ -17904,7 +17895,7 @@
       </p:sp>
       <p:sp>
         <p:nvSpPr>
-          <p:cNvPr id="228" name="Rectangle 11"/>
+          <p:cNvPr id="229" name="Rectangle 11"/>
           <p:cNvSpPr/>
           <p:nvPr/>
         </p:nvSpPr>
@@ -17960,7 +17951,7 @@
       </p:sp>
       <p:sp>
         <p:nvSpPr>
-          <p:cNvPr id="229" name="TextBox 12"/>
+          <p:cNvPr id="230" name="TextBox 12"/>
           <p:cNvSpPr/>
           <p:nvPr/>
         </p:nvSpPr>
@@ -18002,7 +17993,7 @@
                 <a:uFillTx/>
                 <a:latin typeface="Calibri"/>
               </a:rPr>
-              <a:t>3. Non-Maximum Suppression (NMS)</a:t>
+              <a:t>3. Non-Maximum Suppression</a:t>
             </a:r>
             <a:endParaRPr lang="en-US" sz="1400" b="0" u="none" strike="noStrike">
               <a:solidFill>
@@ -18017,7 +18008,7 @@
       </p:sp>
       <p:sp>
         <p:nvSpPr>
-          <p:cNvPr id="230" name="TextBox 13"/>
+          <p:cNvPr id="231" name="TextBox 13"/>
           <p:cNvSpPr/>
           <p:nvPr/>
         </p:nvSpPr>
@@ -18059,7 +18050,7 @@
                 <a:uFillTx/>
                 <a:latin typeface="Calibri"/>
               </a:rPr>
-              <a:t>Overlapping windows for the same class are merged using IoU threshold 0.45, retaining the highest-confidence detection.</a:t>
+              <a:t>Per-class NMS at IoU 0.3, retaining the highest-confidence detection.</a:t>
             </a:r>
             <a:endParaRPr lang="en-US" sz="1200" b="0" u="none" strike="noStrike">
               <a:solidFill>
@@ -18074,7 +18065,7 @@
       </p:sp>
       <p:sp>
         <p:nvSpPr>
-          <p:cNvPr id="231" name="Rectangle 14"/>
+          <p:cNvPr id="232" name="Rectangle 14"/>
           <p:cNvSpPr/>
           <p:nvPr/>
         </p:nvSpPr>
@@ -18130,7 +18121,7 @@
       </p:sp>
       <p:sp>
         <p:nvSpPr>
-          <p:cNvPr id="232" name="TextBox 15"/>
+          <p:cNvPr id="233" name="TextBox 15"/>
           <p:cNvSpPr/>
           <p:nvPr/>
         </p:nvSpPr>
@@ -18187,7 +18178,7 @@
       </p:sp>
       <p:sp>
         <p:nvSpPr>
-          <p:cNvPr id="233" name="TextBox 16"/>
+          <p:cNvPr id="234" name="TextBox 16"/>
           <p:cNvSpPr/>
           <p:nvPr/>
         </p:nvSpPr>
@@ -18229,7 +18220,7 @@
                 <a:uFillTx/>
                 <a:latin typeface="Calibri"/>
               </a:rPr>
-              <a:t>Per-frame class counts written to frame_predictions.csv. Aggregated totals → class_counts.json. Annotated bounding boxes rendered to annotated_output.mp4.</a:t>
+              <a:t>Per-frame class counts → CSV. Aggregated totals → JSON. Annotated bounding boxes → MP4.</a:t>
             </a:r>
             <a:endParaRPr lang="en-US" sz="1200" b="0" u="none" strike="noStrike">
               <a:solidFill>
@@ -18244,7 +18235,7 @@
       </p:sp>
       <p:sp>
         <p:nvSpPr>
-          <p:cNvPr id="234" name="Rectangle 17"/>
+          <p:cNvPr id="235" name="Rectangle 17"/>
           <p:cNvSpPr/>
           <p:nvPr/>
         </p:nvSpPr>
@@ -18300,7 +18291,7 @@
       </p:sp>
       <p:sp>
         <p:nvSpPr>
-          <p:cNvPr id="235" name="TextBox 18"/>
+          <p:cNvPr id="236" name="TextBox 18"/>
           <p:cNvSpPr/>
           <p:nvPr/>
         </p:nvSpPr>
@@ -18342,7 +18333,7 @@
                 <a:uFillTx/>
                 <a:latin typeface="Calibri"/>
               </a:rPr>
-              <a:t>Result: 1,947 detections over a 60-second test video  |  Per-frame density estimates computed</a:t>
+              <a:t>Working video demo with per-frame density estimates  |  Phase 3: replace sliding window with YOLOv8-nano</a:t>
             </a:r>
             <a:endParaRPr lang="en-US" sz="1400" b="0" u="none" strike="noStrike">
               <a:solidFill>
@@ -18357,7 +18348,7 @@
       </p:sp>
       <p:sp>
         <p:nvSpPr>
-          <p:cNvPr id="236" name="TextBox 19"/>
+          <p:cNvPr id="237" name="TextBox 19"/>
           <p:cNvSpPr/>
           <p:nvPr/>
         </p:nvSpPr>
@@ -18414,7 +18405,7 @@
       </p:sp>
       <p:sp>
         <p:nvSpPr>
-          <p:cNvPr id="237" name="Rectangle 20"/>
+          <p:cNvPr id="238" name="Rectangle 20"/>
           <p:cNvSpPr/>
           <p:nvPr/>
         </p:nvSpPr>
@@ -18500,7 +18491,7 @@
       </p:grpSpPr>
       <p:sp>
         <p:nvSpPr>
-          <p:cNvPr id="238" name="Rectangle 1"/>
+          <p:cNvPr id="239" name="Rectangle 1"/>
           <p:cNvSpPr/>
           <p:nvPr/>
         </p:nvSpPr>
@@ -18556,7 +18547,7 @@
       </p:sp>
       <p:sp>
         <p:nvSpPr>
-          <p:cNvPr id="239" name="Rectangle 2"/>
+          <p:cNvPr id="240" name="Rectangle 2"/>
           <p:cNvSpPr/>
           <p:nvPr/>
         </p:nvSpPr>
@@ -18595,7 +18586,7 @@
           <a:fontRef idx="minor"/>
         </p:style>
         <p:txBody>
-          <a:bodyPr wrap="none" lIns="90000" tIns="45000" rIns="90000" bIns="45000" anchor="ctr">
+          <a:bodyPr lIns="90000" tIns="45000" rIns="90000" bIns="45000" anchor="ctr">
             <a:noAutofit/>
           </a:bodyPr>
           <a:p>
@@ -18628,7 +18619,7 @@
       </p:sp>
       <p:sp>
         <p:nvSpPr>
-          <p:cNvPr id="240" name="Rectangle 3"/>
+          <p:cNvPr id="241" name="Rectangle 3"/>
           <p:cNvSpPr/>
           <p:nvPr/>
         </p:nvSpPr>
@@ -18687,7 +18678,7 @@
       </p:sp>
       <p:sp>
         <p:nvSpPr>
-          <p:cNvPr id="241" name="Rectangle 4"/>
+          <p:cNvPr id="242" name="Rectangle 4"/>
           <p:cNvSpPr/>
           <p:nvPr/>
         </p:nvSpPr>
@@ -18743,7 +18734,7 @@
       </p:sp>
       <p:sp>
         <p:nvSpPr>
-          <p:cNvPr id="242" name="TextBox 5"/>
+          <p:cNvPr id="243" name="TextBox 5"/>
           <p:cNvSpPr/>
           <p:nvPr/>
         </p:nvSpPr>
@@ -18800,7 +18791,7 @@
       </p:sp>
       <p:sp>
         <p:nvSpPr>
-          <p:cNvPr id="243" name="TextBox 6"/>
+          <p:cNvPr id="244" name="TextBox 6"/>
           <p:cNvSpPr/>
           <p:nvPr/>
         </p:nvSpPr>
@@ -18842,7 +18833,7 @@
                 <a:uFillTx/>
                 <a:latin typeface="Calibri"/>
               </a:rPr>
-              <a:t>Replace sliding-window with YOLOv8-nano as a pre-processor.  Extract bounding boxes first, then pass each crop to MobileViT classifier.  Expected: &gt;10× speed-up on full-resolution video.</a:t>
+              <a:t>Replace sliding-window with YOLOv8-nano for box proposals; pass each crop to MobileViT classifier. Expected &gt;10× speed-up.</a:t>
             </a:r>
             <a:endParaRPr lang="en-US" sz="1200" b="0" u="none" strike="noStrike">
               <a:solidFill>
@@ -18857,7 +18848,7 @@
       </p:sp>
       <p:sp>
         <p:nvSpPr>
-          <p:cNvPr id="244" name="Rectangle 7"/>
+          <p:cNvPr id="245" name="Rectangle 7"/>
           <p:cNvSpPr/>
           <p:nvPr/>
         </p:nvSpPr>
@@ -18916,7 +18907,7 @@
       </p:sp>
       <p:sp>
         <p:nvSpPr>
-          <p:cNvPr id="245" name="Rectangle 8"/>
+          <p:cNvPr id="246" name="Rectangle 8"/>
           <p:cNvSpPr/>
           <p:nvPr/>
         </p:nvSpPr>
@@ -18972,7 +18963,7 @@
       </p:sp>
       <p:sp>
         <p:nvSpPr>
-          <p:cNvPr id="246" name="TextBox 9"/>
+          <p:cNvPr id="247" name="TextBox 9"/>
           <p:cNvSpPr/>
           <p:nvPr/>
         </p:nvSpPr>
@@ -19029,7 +19020,7 @@
       </p:sp>
       <p:sp>
         <p:nvSpPr>
-          <p:cNvPr id="247" name="TextBox 10"/>
+          <p:cNvPr id="248" name="TextBox 10"/>
           <p:cNvSpPr/>
           <p:nvPr/>
         </p:nvSpPr>
@@ -19071,7 +19062,7 @@
                 <a:uFillTx/>
                 <a:latin typeface="Calibri"/>
               </a:rPr>
-              <a:t>Integrate SORT / ByteTrack to assign persistent IDs across frames.  Eliminates double-counting; enables time-series occupancy curves.</a:t>
+              <a:t>SORT / ByteTrack to assign persistent IDs across frames; eliminates double-counting for time-series occupancy.</a:t>
             </a:r>
             <a:endParaRPr lang="en-US" sz="1200" b="0" u="none" strike="noStrike">
               <a:solidFill>
@@ -19086,7 +19077,7 @@
       </p:sp>
       <p:sp>
         <p:nvSpPr>
-          <p:cNvPr id="248" name="Rectangle 11"/>
+          <p:cNvPr id="249" name="Rectangle 11"/>
           <p:cNvSpPr/>
           <p:nvPr/>
         </p:nvSpPr>
@@ -19145,7 +19136,7 @@
       </p:sp>
       <p:sp>
         <p:nvSpPr>
-          <p:cNvPr id="249" name="Rectangle 12"/>
+          <p:cNvPr id="250" name="Rectangle 12"/>
           <p:cNvSpPr/>
           <p:nvPr/>
         </p:nvSpPr>
@@ -19201,7 +19192,7 @@
       </p:sp>
       <p:sp>
         <p:nvSpPr>
-          <p:cNvPr id="250" name="TextBox 13"/>
+          <p:cNvPr id="251" name="TextBox 13"/>
           <p:cNvSpPr/>
           <p:nvPr/>
         </p:nvSpPr>
@@ -19258,7 +19249,7 @@
       </p:sp>
       <p:sp>
         <p:nvSpPr>
-          <p:cNvPr id="251" name="TextBox 14"/>
+          <p:cNvPr id="252" name="TextBox 14"/>
           <p:cNvSpPr/>
           <p:nvPr/>
         </p:nvSpPr>
@@ -19300,7 +19291,7 @@
                 <a:uFillTx/>
                 <a:latin typeface="Calibri"/>
               </a:rPr>
-              <a:t>FastAPI or Streamlit interface: upload video, view live counts per class.  ROI-based lane counting; density heat-maps; export to JSON/CSV.</a:t>
+              <a:t>FastAPI / Streamlit: upload video, view live counts, ROI lane counting, density heat-maps.</a:t>
             </a:r>
             <a:endParaRPr lang="en-US" sz="1200" b="0" u="none" strike="noStrike">
               <a:solidFill>
@@ -19315,7 +19306,7 @@
       </p:sp>
       <p:sp>
         <p:nvSpPr>
-          <p:cNvPr id="252" name="Rectangle 15"/>
+          <p:cNvPr id="253" name="Rectangle 15"/>
           <p:cNvSpPr/>
           <p:nvPr/>
         </p:nvSpPr>
@@ -19374,7 +19365,7 @@
       </p:sp>
       <p:sp>
         <p:nvSpPr>
-          <p:cNvPr id="253" name="Rectangle 16"/>
+          <p:cNvPr id="254" name="Rectangle 16"/>
           <p:cNvSpPr/>
           <p:nvPr/>
         </p:nvSpPr>
@@ -19430,7 +19421,7 @@
       </p:sp>
       <p:sp>
         <p:nvSpPr>
-          <p:cNvPr id="254" name="TextBox 17"/>
+          <p:cNvPr id="255" name="TextBox 17"/>
           <p:cNvSpPr/>
           <p:nvPr/>
         </p:nvSpPr>
@@ -19487,7 +19478,7 @@
       </p:sp>
       <p:sp>
         <p:nvSpPr>
-          <p:cNvPr id="255" name="TextBox 18"/>
+          <p:cNvPr id="256" name="TextBox 18"/>
           <p:cNvSpPr/>
           <p:nvPr/>
         </p:nvSpPr>
@@ -19529,7 +19520,7 @@
                 <a:uFillTx/>
                 <a:latin typeface="Calibri"/>
               </a:rPr>
-              <a:t>RTSP stream ingestion for live traffic camera integration.  Target latency: &lt;200 ms/frame on GPU.</a:t>
+              <a:t>RTSP stream ingestion for live camera integration; target latency &lt;200 ms/frame on GPU.</a:t>
             </a:r>
             <a:endParaRPr lang="en-US" sz="1200" b="0" u="none" strike="noStrike">
               <a:solidFill>
@@ -19544,7 +19535,7 @@
       </p:sp>
       <p:sp>
         <p:nvSpPr>
-          <p:cNvPr id="256" name="Rectangle 19"/>
+          <p:cNvPr id="257" name="Rectangle 19"/>
           <p:cNvSpPr/>
           <p:nvPr/>
         </p:nvSpPr>
@@ -19600,7 +19591,7 @@
       </p:sp>
       <p:sp>
         <p:nvSpPr>
-          <p:cNvPr id="257" name="TextBox 21"/>
+          <p:cNvPr id="258" name="TextBox 21"/>
           <p:cNvSpPr/>
           <p:nvPr/>
         </p:nvSpPr>
@@ -19657,7 +19648,7 @@
       </p:sp>
       <p:sp>
         <p:nvSpPr>
-          <p:cNvPr id="258" name="Rectangle 22"/>
+          <p:cNvPr id="259" name="Rectangle 22"/>
           <p:cNvSpPr/>
           <p:nvPr/>
         </p:nvSpPr>

</xml_diff>